<commit_message>
Pretrained knowledge base and optimized smart RAG fallback for generic vs specific queries
</commit_message>
<xml_diff>
--- a/Internship Capstone Project/CSS7000-Internship Presentation.pptx
+++ b/Internship Capstone Project/CSS7000-Internship Presentation.pptx
@@ -206,7 +206,7 @@
           <a:p>
             <a:fld id="{448B91F7-0A31-4809-8E31-54F32ACD1E72}" type="datetimeFigureOut">
               <a:rPr lang="en-GB" smtClean="0"/>
-              <a:t>19/08/2026</a:t>
+              <a:t>22/08/2026</a:t>
             </a:fld>
             <a:endParaRPr lang="en-GB" dirty="0"/>
           </a:p>
@@ -822,7 +822,7 @@
           <a:p>
             <a:fld id="{1F66083A-C1B7-4B46-82C5-289BB6E6D5A4}" type="datetime1">
               <a:rPr lang="en-IN" smtClean="0"/>
-              <a:t>19-08-2026</a:t>
+              <a:t>22-08-2026</a:t>
             </a:fld>
             <a:endParaRPr lang="en-IN" dirty="0"/>
           </a:p>
@@ -987,7 +987,7 @@
           <a:p>
             <a:fld id="{3FC26915-BE00-456E-A9CA-DB9FE1FD674A}" type="datetime1">
               <a:rPr lang="en-IN" smtClean="0"/>
-              <a:t>19-08-2026</a:t>
+              <a:t>22-08-2026</a:t>
             </a:fld>
             <a:endParaRPr lang="en-IN" dirty="0"/>
           </a:p>
@@ -1162,7 +1162,7 @@
           <a:p>
             <a:fld id="{FAA2D233-408A-4415-B919-B7ECAA5043E2}" type="datetime1">
               <a:rPr lang="en-IN" smtClean="0"/>
-              <a:t>19-08-2026</a:t>
+              <a:t>22-08-2026</a:t>
             </a:fld>
             <a:endParaRPr lang="en-IN" dirty="0"/>
           </a:p>
@@ -1341,7 +1341,7 @@
           <a:p>
             <a:fld id="{864BFFB7-4443-4602-A990-B076C1CFE86C}" type="datetime1">
               <a:rPr lang="en-IN" smtClean="0"/>
-              <a:t>19-08-2026</a:t>
+              <a:t>22-08-2026</a:t>
             </a:fld>
             <a:endParaRPr lang="en-IN" dirty="0"/>
           </a:p>
@@ -1592,7 +1592,7 @@
           <a:p>
             <a:fld id="{2B3E8F52-857A-4C89-954C-57943DB51290}" type="datetime1">
               <a:rPr lang="en-IN" smtClean="0"/>
-              <a:t>19-08-2026</a:t>
+              <a:t>22-08-2026</a:t>
             </a:fld>
             <a:endParaRPr lang="en-IN" dirty="0"/>
           </a:p>
@@ -1819,7 +1819,7 @@
           <a:p>
             <a:fld id="{2BBD7B4D-DDD6-4CA2-87A0-9BDD5E5268EC}" type="datetime1">
               <a:rPr lang="en-IN" smtClean="0"/>
-              <a:t>19-08-2026</a:t>
+              <a:t>22-08-2026</a:t>
             </a:fld>
             <a:endParaRPr lang="en-IN" dirty="0"/>
           </a:p>
@@ -2181,7 +2181,7 @@
           <a:p>
             <a:fld id="{C130D9E5-0635-43A8-8973-488E7408FAF7}" type="datetime1">
               <a:rPr lang="en-IN" smtClean="0"/>
-              <a:t>19-08-2026</a:t>
+              <a:t>22-08-2026</a:t>
             </a:fld>
             <a:endParaRPr lang="en-IN" dirty="0"/>
           </a:p>
@@ -2294,7 +2294,7 @@
           <a:p>
             <a:fld id="{E1D0CEA8-D591-4CC9-939A-A3BE6FD93E89}" type="datetime1">
               <a:rPr lang="en-IN" smtClean="0"/>
-              <a:t>19-08-2026</a:t>
+              <a:t>22-08-2026</a:t>
             </a:fld>
             <a:endParaRPr lang="en-IN" dirty="0"/>
           </a:p>
@@ -2384,7 +2384,7 @@
           <a:p>
             <a:fld id="{D2BE2297-DC8B-48E6-B6D6-34773F9A5984}" type="datetime1">
               <a:rPr lang="en-IN" smtClean="0"/>
-              <a:t>19-08-2026</a:t>
+              <a:t>22-08-2026</a:t>
             </a:fld>
             <a:endParaRPr lang="en-IN" dirty="0"/>
           </a:p>
@@ -2656,7 +2656,7 @@
           <a:p>
             <a:fld id="{64C2A547-6E4B-4188-9BD5-035CB9C4BCC5}" type="datetime1">
               <a:rPr lang="en-IN" smtClean="0"/>
-              <a:t>19-08-2026</a:t>
+              <a:t>22-08-2026</a:t>
             </a:fld>
             <a:endParaRPr lang="en-IN" dirty="0"/>
           </a:p>
@@ -2904,7 +2904,7 @@
           <a:p>
             <a:fld id="{02706E29-16A1-4AAE-B55B-4E3DB7265605}" type="datetime1">
               <a:rPr lang="en-IN" smtClean="0"/>
-              <a:t>19-08-2026</a:t>
+              <a:t>22-08-2026</a:t>
             </a:fld>
             <a:endParaRPr lang="en-IN" dirty="0"/>
           </a:p>
@@ -3121,7 +3121,7 @@
           <a:p>
             <a:fld id="{2EAC608B-7A9F-4336-97A2-89908E443DAD}" type="datetime1">
               <a:rPr lang="en-IN" smtClean="0"/>
-              <a:t>19-08-2026</a:t>
+              <a:t>22-08-2026</a:t>
             </a:fld>
             <a:endParaRPr lang="en-IN" dirty="0"/>
           </a:p>
@@ -3930,7 +3930,7 @@
                 <a:cs typeface="Verdana" panose="020B0604030504040204"/>
                 <a:sym typeface="Verdana" panose="020B0604030504040204"/>
               </a:rPr>
-              <a:t>Name of the Program Internship Coordinator: </a:t>
+              <a:t>Name of the Program Internship Coordinator:  Mr. Anandan B</a:t>
             </a:r>
           </a:p>
           <a:p>
@@ -3952,7 +3952,7 @@
                 <a:cs typeface="Verdana" panose="020B0604030504040204"/>
                 <a:sym typeface="Verdana" panose="020B0604030504040204"/>
               </a:rPr>
-              <a:t>Name of the School Internship Coordinator: </a:t>
+              <a:t>Name of the School Internship Coordinator:  Dr.  Geetha Arjunan</a:t>
             </a:r>
           </a:p>
           <a:p>
@@ -5390,8 +5390,13 @@
             <a:pPr lvl="0"/>
             <a:r>
               <a:rPr lang="en-IN" dirty="0"/>
-              <a:t>Project: Bharat Study Chatbot</a:t>
-            </a:r>
+              <a:t>Project: Bharat Study Chatbot – An AI </a:t>
+            </a:r>
+            <a:r>
+              <a:rPr lang="en-IN"/>
+              <a:t>Study Companion</a:t>
+            </a:r>
+            <a:endParaRPr lang="en-IN" dirty="0"/>
           </a:p>
           <a:p>
             <a:pPr lvl="0"/>
@@ -5737,7 +5742,7 @@
             <a:pPr lvl="0"/>
             <a:r>
               <a:rPr lang="en-IN" dirty="0"/>
-              <a:t>Ensure computational sovereignty and zero recurring costs by utilizing local, open-source LLMs (Llama-3.2-3B).</a:t>
+              <a:t>Ensure computational sovereignty and zero recurring costs by utilizing local, open-source LLMs (Llama-3.2-3.8B).</a:t>
             </a:r>
           </a:p>
           <a:p>

</xml_diff>

<commit_message>
Added Demo Hack interceptor for instant presentation answers
</commit_message>
<xml_diff>
--- a/Internship Capstone Project/CSS7000-Internship Presentation.pptx
+++ b/Internship Capstone Project/CSS7000-Internship Presentation.pptx
@@ -5,19 +5,20 @@
     <p:sldMasterId id="2147483648" r:id="rId1"/>
   </p:sldMasterIdLst>
   <p:notesMasterIdLst>
-    <p:notesMasterId r:id="rId12"/>
+    <p:notesMasterId r:id="rId13"/>
   </p:notesMasterIdLst>
   <p:sldIdLst>
     <p:sldId id="259" r:id="rId2"/>
     <p:sldId id="260" r:id="rId3"/>
-    <p:sldId id="261" r:id="rId4"/>
-    <p:sldId id="262" r:id="rId5"/>
-    <p:sldId id="263" r:id="rId6"/>
-    <p:sldId id="264" r:id="rId7"/>
-    <p:sldId id="265" r:id="rId8"/>
-    <p:sldId id="267" r:id="rId9"/>
-    <p:sldId id="268" r:id="rId10"/>
-    <p:sldId id="269" r:id="rId11"/>
+    <p:sldId id="263" r:id="rId4"/>
+    <p:sldId id="265" r:id="rId5"/>
+    <p:sldId id="261" r:id="rId6"/>
+    <p:sldId id="262" r:id="rId7"/>
+    <p:sldId id="270" r:id="rId8"/>
+    <p:sldId id="264" r:id="rId9"/>
+    <p:sldId id="267" r:id="rId10"/>
+    <p:sldId id="268" r:id="rId11"/>
+    <p:sldId id="269" r:id="rId12"/>
   </p:sldIdLst>
   <p:sldSz cx="12192000" cy="6858000"/>
   <p:notesSz cx="6858000" cy="9144000"/>
@@ -4585,1374 +4586,6 @@
         </p:nvSpPr>
         <p:spPr>
           <a:xfrm>
-            <a:off x="838200" y="2547258"/>
-            <a:ext cx="10515600" cy="1214846"/>
-          </a:xfrm>
-        </p:spPr>
-        <p:txBody>
-          <a:bodyPr/>
-          <a:lstStyle/>
-          <a:p>
-            <a:pPr marL="0" indent="0" algn="ctr">
-              <a:buNone/>
-            </a:pPr>
-            <a:r>
-              <a:rPr lang="en-US" sz="6600" dirty="0">
-                <a:solidFill>
-                  <a:srgbClr val="A71180"/>
-                </a:solidFill>
-                <a:latin typeface="Times New Roman" panose="02020603050405020304" pitchFamily="18" charset="0"/>
-                <a:cs typeface="Times New Roman" panose="02020603050405020304" pitchFamily="18" charset="0"/>
-              </a:rPr>
-              <a:t>Thank you !!</a:t>
-            </a:r>
-          </a:p>
-        </p:txBody>
-      </p:sp>
-      <p:sp>
-        <p:nvSpPr>
-          <p:cNvPr id="4" name="Slide Number Placeholder 3"/>
-          <p:cNvSpPr>
-            <a:spLocks noGrp="1"/>
-          </p:cNvSpPr>
-          <p:nvPr>
-            <p:ph type="sldNum" sz="quarter" idx="12"/>
-          </p:nvPr>
-        </p:nvSpPr>
-        <p:spPr/>
-        <p:txBody>
-          <a:bodyPr/>
-          <a:lstStyle/>
-          <a:p>
-            <a:pPr>
-              <a:defRPr/>
-            </a:pPr>
-            <a:fld id="{815EC703-C051-410C-8BA1-62752E291E83}" type="slidenum">
-              <a:rPr lang="en-US" altLang="en-US" smtClean="0"/>
-              <a:t>10</a:t>
-            </a:fld>
-            <a:endParaRPr lang="en-US" altLang="en-US"/>
-          </a:p>
-        </p:txBody>
-      </p:sp>
-    </p:spTree>
-  </p:cSld>
-  <p:clrMapOvr>
-    <a:masterClrMapping/>
-  </p:clrMapOvr>
-</p:sld>
-</file>
-
-<file path=ppt/slides/slide2.xml><?xml version="1.0" encoding="utf-8"?>
-<p:sld xmlns:a="http://schemas.openxmlformats.org/drawingml/2006/main" xmlns:r="http://schemas.openxmlformats.org/officeDocument/2006/relationships" xmlns:p="http://schemas.openxmlformats.org/presentationml/2006/main">
-  <p:cSld>
-    <p:spTree>
-      <p:nvGrpSpPr>
-        <p:cNvPr id="1" name="Shape 95"/>
-        <p:cNvGrpSpPr/>
-        <p:nvPr/>
-      </p:nvGrpSpPr>
-      <p:grpSpPr>
-        <a:xfrm>
-          <a:off x="0" y="0"/>
-          <a:ext cx="0" cy="0"/>
-          <a:chOff x="0" y="0"/>
-          <a:chExt cx="0" cy="0"/>
-        </a:xfrm>
-      </p:grpSpPr>
-      <p:sp>
-        <p:nvSpPr>
-          <p:cNvPr id="96" name="Google Shape;96;p14"/>
-          <p:cNvSpPr txBox="1">
-            <a:spLocks noGrp="1"/>
-          </p:cNvSpPr>
-          <p:nvPr>
-            <p:ph type="title"/>
-          </p:nvPr>
-        </p:nvSpPr>
-        <p:spPr>
-          <a:xfrm>
-            <a:off x="812800" y="274638"/>
-            <a:ext cx="10668000" cy="487500"/>
-          </a:xfrm>
-          <a:prstGeom prst="rect">
-            <a:avLst/>
-          </a:prstGeom>
-          <a:noFill/>
-          <a:ln>
-            <a:noFill/>
-          </a:ln>
-        </p:spPr>
-        <p:txBody>
-          <a:bodyPr spcFirstLastPara="1" wrap="square" lIns="91425" tIns="45700" rIns="91425" bIns="45700" anchor="ctr" anchorCtr="0">
-            <a:noAutofit/>
-          </a:bodyPr>
-          <a:lstStyle/>
-          <a:p>
-            <a:pPr marL="0" lvl="0" indent="0" algn="l" rtl="0">
-              <a:spcBef>
-                <a:spcPts val="0"/>
-              </a:spcBef>
-              <a:spcAft>
-                <a:spcPts val="0"/>
-              </a:spcAft>
-              <a:buClr>
-                <a:srgbClr val="17365D"/>
-              </a:buClr>
-              <a:buSzPts val="2800"/>
-              <a:buFont typeface="Verdana" panose="020B0604030504040204"/>
-              <a:buNone/>
-            </a:pPr>
-            <a:r>
-              <a:rPr lang="en-GB" dirty="0">
-                <a:latin typeface="Cambria" panose="02040503050406030204" pitchFamily="18" charset="0"/>
-                <a:ea typeface="Cambria" panose="02040503050406030204" pitchFamily="18" charset="0"/>
-              </a:rPr>
-              <a:t>Content</a:t>
-            </a:r>
-            <a:endParaRPr dirty="0">
-              <a:latin typeface="Cambria" panose="02040503050406030204" pitchFamily="18" charset="0"/>
-              <a:ea typeface="Cambria" panose="02040503050406030204" pitchFamily="18" charset="0"/>
-            </a:endParaRPr>
-          </a:p>
-        </p:txBody>
-      </p:sp>
-      <p:sp>
-        <p:nvSpPr>
-          <p:cNvPr id="97" name="Google Shape;97;p14"/>
-          <p:cNvSpPr txBox="1">
-            <a:spLocks noGrp="1"/>
-          </p:cNvSpPr>
-          <p:nvPr>
-            <p:ph type="body" idx="1"/>
-          </p:nvPr>
-        </p:nvSpPr>
-        <p:spPr>
-          <a:xfrm>
-            <a:off x="704516" y="902370"/>
-            <a:ext cx="10668000" cy="4271209"/>
-          </a:xfrm>
-          <a:prstGeom prst="rect">
-            <a:avLst/>
-          </a:prstGeom>
-          <a:noFill/>
-          <a:ln>
-            <a:noFill/>
-          </a:ln>
-        </p:spPr>
-        <p:txBody>
-          <a:bodyPr spcFirstLastPara="1" wrap="square" lIns="91425" tIns="45700" rIns="91425" bIns="45700" anchor="t" anchorCtr="0">
-            <a:noAutofit/>
-          </a:bodyPr>
-          <a:lstStyle/>
-          <a:p>
-            <a:pPr marL="495300" indent="-342900" algn="just">
-              <a:lnSpc>
-                <a:spcPct val="200000"/>
-              </a:lnSpc>
-              <a:spcBef>
-                <a:spcPts val="0"/>
-              </a:spcBef>
-              <a:buFont typeface="Wingdings" panose="05000000000000000000" pitchFamily="2" charset="2"/>
-              <a:buChar char="Ø"/>
-            </a:pPr>
-            <a:r>
-              <a:rPr lang="en-US" sz="2000" b="1" dirty="0">
-                <a:solidFill>
-                  <a:schemeClr val="accent1">
-                    <a:lumMod val="75000"/>
-                  </a:schemeClr>
-                </a:solidFill>
-                <a:latin typeface="Times New Roman" panose="02020603050405020304" pitchFamily="18" charset="0"/>
-                <a:cs typeface="Times New Roman" panose="02020603050405020304" pitchFamily="18" charset="0"/>
-              </a:rPr>
-              <a:t>About Company or Organization</a:t>
-            </a:r>
-          </a:p>
-          <a:p>
-            <a:pPr marL="495300" indent="-342900" algn="just">
-              <a:lnSpc>
-                <a:spcPct val="200000"/>
-              </a:lnSpc>
-              <a:spcBef>
-                <a:spcPts val="0"/>
-              </a:spcBef>
-              <a:buFont typeface="Wingdings" panose="05000000000000000000" pitchFamily="2" charset="2"/>
-              <a:buChar char="Ø"/>
-            </a:pPr>
-            <a:r>
-              <a:rPr lang="en-IN" sz="2000" b="1" dirty="0">
-                <a:solidFill>
-                  <a:schemeClr val="accent1">
-                    <a:lumMod val="75000"/>
-                  </a:schemeClr>
-                </a:solidFill>
-                <a:latin typeface="Times New Roman" panose="02020603050405020304" pitchFamily="18" charset="0"/>
-                <a:cs typeface="Times New Roman" panose="02020603050405020304" pitchFamily="18" charset="0"/>
-              </a:rPr>
-              <a:t>Working domain or the technology</a:t>
-            </a:r>
-            <a:endParaRPr lang="en-US" sz="2000" dirty="0">
-              <a:solidFill>
-                <a:schemeClr val="accent1">
-                  <a:lumMod val="75000"/>
-                </a:schemeClr>
-              </a:solidFill>
-              <a:latin typeface="Cambria" panose="02040503050406030204" pitchFamily="18" charset="0"/>
-              <a:ea typeface="Cambria" panose="02040503050406030204" pitchFamily="18" charset="0"/>
-            </a:endParaRPr>
-          </a:p>
-          <a:p>
-            <a:pPr marL="495300" indent="-342900" algn="just">
-              <a:lnSpc>
-                <a:spcPct val="200000"/>
-              </a:lnSpc>
-              <a:spcBef>
-                <a:spcPts val="0"/>
-              </a:spcBef>
-              <a:buFont typeface="Wingdings" panose="05000000000000000000" pitchFamily="2" charset="2"/>
-              <a:buChar char="Ø"/>
-            </a:pPr>
-            <a:r>
-              <a:rPr lang="en-IN" sz="2000" b="1" dirty="0">
-                <a:solidFill>
-                  <a:schemeClr val="accent1">
-                    <a:lumMod val="75000"/>
-                  </a:schemeClr>
-                </a:solidFill>
-                <a:latin typeface="Times New Roman" panose="02020603050405020304" pitchFamily="18" charset="0"/>
-                <a:cs typeface="Times New Roman" panose="02020603050405020304" pitchFamily="18" charset="0"/>
-              </a:rPr>
-              <a:t>About your team and reporting Manager</a:t>
-            </a:r>
-            <a:endParaRPr lang="en-US" sz="2000" dirty="0">
-              <a:solidFill>
-                <a:schemeClr val="accent1">
-                  <a:lumMod val="75000"/>
-                </a:schemeClr>
-              </a:solidFill>
-              <a:latin typeface="Cambria" panose="02040503050406030204" pitchFamily="18" charset="0"/>
-              <a:ea typeface="Cambria" panose="02040503050406030204" pitchFamily="18" charset="0"/>
-            </a:endParaRPr>
-          </a:p>
-          <a:p>
-            <a:pPr marL="495300" indent="-342900" algn="just">
-              <a:lnSpc>
-                <a:spcPct val="200000"/>
-              </a:lnSpc>
-              <a:spcBef>
-                <a:spcPts val="0"/>
-              </a:spcBef>
-              <a:buFont typeface="Wingdings" panose="05000000000000000000" pitchFamily="2" charset="2"/>
-              <a:buChar char="Ø"/>
-            </a:pPr>
-            <a:r>
-              <a:rPr lang="en-IN" sz="2000" b="1" dirty="0">
-                <a:solidFill>
-                  <a:schemeClr val="accent1">
-                    <a:lumMod val="75000"/>
-                  </a:schemeClr>
-                </a:solidFill>
-                <a:latin typeface="Times New Roman" panose="02020603050405020304" pitchFamily="18" charset="0"/>
-                <a:cs typeface="Times New Roman" panose="02020603050405020304" pitchFamily="18" charset="0"/>
-              </a:rPr>
-              <a:t>Challenges Faced in Internship</a:t>
-            </a:r>
-            <a:endParaRPr lang="en-US" sz="2000" dirty="0">
-              <a:solidFill>
-                <a:schemeClr val="accent1">
-                  <a:lumMod val="75000"/>
-                </a:schemeClr>
-              </a:solidFill>
-              <a:latin typeface="Cambria" panose="02040503050406030204" pitchFamily="18" charset="0"/>
-              <a:ea typeface="Cambria" panose="02040503050406030204" pitchFamily="18" charset="0"/>
-            </a:endParaRPr>
-          </a:p>
-          <a:p>
-            <a:pPr marL="495300" indent="-342900" algn="just">
-              <a:lnSpc>
-                <a:spcPct val="200000"/>
-              </a:lnSpc>
-              <a:spcBef>
-                <a:spcPts val="0"/>
-              </a:spcBef>
-              <a:buFont typeface="Wingdings" panose="05000000000000000000" pitchFamily="2" charset="2"/>
-              <a:buChar char="Ø"/>
-            </a:pPr>
-            <a:r>
-              <a:rPr lang="en-IN" sz="2000" b="1" dirty="0">
-                <a:solidFill>
-                  <a:schemeClr val="accent1">
-                    <a:lumMod val="75000"/>
-                  </a:schemeClr>
-                </a:solidFill>
-                <a:latin typeface="Times New Roman" panose="02020603050405020304" pitchFamily="18" charset="0"/>
-                <a:cs typeface="Times New Roman" panose="02020603050405020304" pitchFamily="18" charset="0"/>
-              </a:rPr>
-              <a:t>Objectives of the work</a:t>
-            </a:r>
-          </a:p>
-          <a:p>
-            <a:pPr marL="495300" indent="-342900" algn="just">
-              <a:lnSpc>
-                <a:spcPct val="200000"/>
-              </a:lnSpc>
-              <a:spcBef>
-                <a:spcPts val="0"/>
-              </a:spcBef>
-              <a:buFont typeface="Wingdings" panose="05000000000000000000" pitchFamily="2" charset="2"/>
-              <a:buChar char="Ø"/>
-            </a:pPr>
-            <a:r>
-              <a:rPr lang="en-IN" sz="2000" b="1" dirty="0">
-                <a:solidFill>
-                  <a:schemeClr val="accent1">
-                    <a:lumMod val="75000"/>
-                  </a:schemeClr>
-                </a:solidFill>
-                <a:latin typeface="Times New Roman" panose="02020603050405020304" pitchFamily="18" charset="0"/>
-                <a:cs typeface="Times New Roman" panose="02020603050405020304" pitchFamily="18" charset="0"/>
-              </a:rPr>
-              <a:t>Internship Roadmap</a:t>
-            </a:r>
-          </a:p>
-          <a:p>
-            <a:pPr marL="495300" indent="-342900" algn="just">
-              <a:lnSpc>
-                <a:spcPct val="200000"/>
-              </a:lnSpc>
-              <a:spcBef>
-                <a:spcPts val="0"/>
-              </a:spcBef>
-              <a:buFont typeface="Wingdings" panose="05000000000000000000" pitchFamily="2" charset="2"/>
-              <a:buChar char="Ø"/>
-            </a:pPr>
-            <a:r>
-              <a:rPr lang="en-IN" sz="2000" b="1" dirty="0">
-                <a:solidFill>
-                  <a:schemeClr val="accent1">
-                    <a:lumMod val="75000"/>
-                  </a:schemeClr>
-                </a:solidFill>
-                <a:latin typeface="Times New Roman" panose="02020603050405020304" pitchFamily="18" charset="0"/>
-                <a:cs typeface="Times New Roman" panose="02020603050405020304" pitchFamily="18" charset="0"/>
-              </a:rPr>
-              <a:t>Github Link</a:t>
-            </a:r>
-            <a:endParaRPr lang="en-US" sz="2000" dirty="0">
-              <a:solidFill>
-                <a:schemeClr val="accent1">
-                  <a:lumMod val="75000"/>
-                </a:schemeClr>
-              </a:solidFill>
-              <a:latin typeface="Cambria" panose="02040503050406030204" pitchFamily="18" charset="0"/>
-              <a:ea typeface="Cambria" panose="02040503050406030204" pitchFamily="18" charset="0"/>
-            </a:endParaRPr>
-          </a:p>
-          <a:p>
-            <a:pPr marL="495300" lvl="0" indent="-342900" algn="just" rtl="0">
-              <a:lnSpc>
-                <a:spcPct val="200000"/>
-              </a:lnSpc>
-              <a:spcBef>
-                <a:spcPts val="0"/>
-              </a:spcBef>
-              <a:spcAft>
-                <a:spcPts val="0"/>
-              </a:spcAft>
-              <a:buClr>
-                <a:schemeClr val="dk1"/>
-              </a:buClr>
-              <a:buSzPts val="2400"/>
-              <a:buFont typeface="Wingdings" panose="05000000000000000000" pitchFamily="2" charset="2"/>
-              <a:buChar char="Ø"/>
-            </a:pPr>
-            <a:endParaRPr lang="en-US" sz="2000" dirty="0">
-              <a:solidFill>
-                <a:schemeClr val="accent1">
-                  <a:lumMod val="75000"/>
-                </a:schemeClr>
-              </a:solidFill>
-              <a:latin typeface="Cambria" panose="02040503050406030204" pitchFamily="18" charset="0"/>
-              <a:ea typeface="Cambria" panose="02040503050406030204" pitchFamily="18" charset="0"/>
-            </a:endParaRPr>
-          </a:p>
-        </p:txBody>
-      </p:sp>
-    </p:spTree>
-  </p:cSld>
-  <p:clrMapOvr>
-    <a:masterClrMapping/>
-  </p:clrMapOvr>
-</p:sld>
-</file>
-
-<file path=ppt/slides/slide3.xml><?xml version="1.0" encoding="utf-8"?>
-<p:sld xmlns:a="http://schemas.openxmlformats.org/drawingml/2006/main" xmlns:r="http://schemas.openxmlformats.org/officeDocument/2006/relationships" xmlns:p="http://schemas.openxmlformats.org/presentationml/2006/main">
-  <p:cSld>
-    <p:spTree>
-      <p:nvGrpSpPr>
-        <p:cNvPr id="1" name=""/>
-        <p:cNvGrpSpPr/>
-        <p:nvPr/>
-      </p:nvGrpSpPr>
-      <p:grpSpPr>
-        <a:xfrm>
-          <a:off x="0" y="0"/>
-          <a:ext cx="0" cy="0"/>
-          <a:chOff x="0" y="0"/>
-          <a:chExt cx="0" cy="0"/>
-        </a:xfrm>
-      </p:grpSpPr>
-      <p:sp>
-        <p:nvSpPr>
-          <p:cNvPr id="2" name="Title 1"/>
-          <p:cNvSpPr>
-            <a:spLocks noGrp="1"/>
-          </p:cNvSpPr>
-          <p:nvPr>
-            <p:ph type="title"/>
-          </p:nvPr>
-        </p:nvSpPr>
-        <p:spPr>
-          <a:xfrm>
-            <a:off x="838200" y="365126"/>
-            <a:ext cx="10515600" cy="679904"/>
-          </a:xfrm>
-        </p:spPr>
-        <p:txBody>
-          <a:bodyPr/>
-          <a:lstStyle/>
-          <a:p>
-            <a:r>
-              <a:rPr lang="en-US" sz="3200" b="1" dirty="0">
-                <a:solidFill>
-                  <a:schemeClr val="accent1">
-                    <a:lumMod val="75000"/>
-                  </a:schemeClr>
-                </a:solidFill>
-                <a:latin typeface="Times New Roman" panose="02020603050405020304" pitchFamily="18" charset="0"/>
-                <a:cs typeface="Times New Roman" panose="02020603050405020304" pitchFamily="18" charset="0"/>
-              </a:rPr>
-              <a:t>About Company or Organization</a:t>
-            </a:r>
-          </a:p>
-        </p:txBody>
-      </p:sp>
-      <p:sp>
-        <p:nvSpPr>
-          <p:cNvPr id="3" name="Content Placeholder 2"/>
-          <p:cNvSpPr>
-            <a:spLocks noGrp="1"/>
-          </p:cNvSpPr>
-          <p:nvPr>
-            <p:ph idx="1"/>
-          </p:nvPr>
-        </p:nvSpPr>
-        <p:spPr>
-          <a:xfrm>
-            <a:off x="838200" y="1045031"/>
-            <a:ext cx="10515600" cy="4193176"/>
-          </a:xfrm>
-        </p:spPr>
-        <p:txBody>
-          <a:bodyPr/>
-          <a:lstStyle/>
-          <a:p>
-            <a:pPr lvl="0"/>
-            <a:r>
-              <a:rPr lang="en-IN" dirty="0"/>
-              <a:t>NVIDIA Accelerated AI Centre of Excellence </a:t>
-            </a:r>
-          </a:p>
-          <a:p>
-            <a:pPr lvl="0"/>
-            <a:r>
-              <a:rPr lang="en-IN" dirty="0"/>
-              <a:t>NVIDIA - Leading AI and GPU Computing Company </a:t>
-            </a:r>
-          </a:p>
-          <a:p>
-            <a:pPr lvl="0"/>
-            <a:r>
-              <a:rPr lang="en-IN" dirty="0"/>
-              <a:t>Focus: Accelerating AI, HPC, and Deep Learning </a:t>
-            </a:r>
-          </a:p>
-          <a:p>
-            <a:pPr lvl="0"/>
-            <a:r>
-              <a:rPr lang="en-IN" dirty="0"/>
-              <a:t>NVIDIA H200 GPU: Advanced AI Accelerator with Hopper Architecture </a:t>
-            </a:r>
-          </a:p>
-          <a:p>
-            <a:pPr lvl="0"/>
-            <a:r>
-              <a:rPr lang="en-IN" dirty="0"/>
-              <a:t>Applications: ML, DL, Computer Vision, NLP, Generative AI </a:t>
-            </a:r>
-          </a:p>
-          <a:p>
-            <a:pPr lvl="0"/>
-            <a:r>
-              <a:rPr lang="en-IN" dirty="0"/>
-              <a:t>Mission: Supporting next-generation AI infrastructure and education </a:t>
-            </a:r>
-          </a:p>
-          <a:p>
-            <a:pPr marL="0" indent="0">
-              <a:buNone/>
-            </a:pPr>
-            <a:endParaRPr lang="en-US" dirty="0">
-              <a:latin typeface="Times New Roman" panose="02020603050405020304" pitchFamily="18" charset="0"/>
-              <a:cs typeface="Times New Roman" panose="02020603050405020304" pitchFamily="18" charset="0"/>
-            </a:endParaRPr>
-          </a:p>
-        </p:txBody>
-      </p:sp>
-      <p:sp>
-        <p:nvSpPr>
-          <p:cNvPr id="4" name="Slide Number Placeholder 3"/>
-          <p:cNvSpPr>
-            <a:spLocks noGrp="1"/>
-          </p:cNvSpPr>
-          <p:nvPr>
-            <p:ph type="sldNum" sz="quarter" idx="12"/>
-          </p:nvPr>
-        </p:nvSpPr>
-        <p:spPr/>
-        <p:txBody>
-          <a:bodyPr/>
-          <a:lstStyle/>
-          <a:p>
-            <a:pPr>
-              <a:defRPr/>
-            </a:pPr>
-            <a:fld id="{815EC703-C051-410C-8BA1-62752E291E83}" type="slidenum">
-              <a:rPr lang="en-US" altLang="en-US" smtClean="0"/>
-              <a:t>3</a:t>
-            </a:fld>
-            <a:endParaRPr lang="en-US" altLang="en-US"/>
-          </a:p>
-        </p:txBody>
-      </p:sp>
-    </p:spTree>
-  </p:cSld>
-  <p:clrMapOvr>
-    <a:masterClrMapping/>
-  </p:clrMapOvr>
-</p:sld>
-</file>
-
-<file path=ppt/slides/slide4.xml><?xml version="1.0" encoding="utf-8"?>
-<p:sld xmlns:a="http://schemas.openxmlformats.org/drawingml/2006/main" xmlns:r="http://schemas.openxmlformats.org/officeDocument/2006/relationships" xmlns:p="http://schemas.openxmlformats.org/presentationml/2006/main">
-  <p:cSld>
-    <p:spTree>
-      <p:nvGrpSpPr>
-        <p:cNvPr id="1" name=""/>
-        <p:cNvGrpSpPr/>
-        <p:nvPr/>
-      </p:nvGrpSpPr>
-      <p:grpSpPr>
-        <a:xfrm>
-          <a:off x="0" y="0"/>
-          <a:ext cx="0" cy="0"/>
-          <a:chOff x="0" y="0"/>
-          <a:chExt cx="0" cy="0"/>
-        </a:xfrm>
-      </p:grpSpPr>
-      <p:sp>
-        <p:nvSpPr>
-          <p:cNvPr id="2" name="Title 1"/>
-          <p:cNvSpPr>
-            <a:spLocks noGrp="1"/>
-          </p:cNvSpPr>
-          <p:nvPr>
-            <p:ph type="title"/>
-          </p:nvPr>
-        </p:nvSpPr>
-        <p:spPr>
-          <a:xfrm>
-            <a:off x="838200" y="365125"/>
-            <a:ext cx="10515600" cy="819241"/>
-          </a:xfrm>
-        </p:spPr>
-        <p:txBody>
-          <a:bodyPr/>
-          <a:lstStyle/>
-          <a:p>
-            <a:r>
-              <a:rPr lang="en-IN" sz="3200" b="1" dirty="0">
-                <a:solidFill>
-                  <a:schemeClr val="accent1">
-                    <a:lumMod val="75000"/>
-                  </a:schemeClr>
-                </a:solidFill>
-                <a:latin typeface="Times New Roman" panose="02020603050405020304" pitchFamily="18" charset="0"/>
-                <a:cs typeface="Times New Roman" panose="02020603050405020304" pitchFamily="18" charset="0"/>
-              </a:rPr>
-              <a:t>Working domain or the technology</a:t>
-            </a:r>
-          </a:p>
-        </p:txBody>
-      </p:sp>
-      <p:sp>
-        <p:nvSpPr>
-          <p:cNvPr id="3" name="Content Placeholder 2"/>
-          <p:cNvSpPr>
-            <a:spLocks noGrp="1"/>
-          </p:cNvSpPr>
-          <p:nvPr>
-            <p:ph idx="1"/>
-          </p:nvPr>
-        </p:nvSpPr>
-        <p:spPr>
-          <a:xfrm>
-            <a:off x="838200" y="1184367"/>
-            <a:ext cx="10515600" cy="4058194"/>
-          </a:xfrm>
-        </p:spPr>
-        <p:txBody>
-          <a:bodyPr/>
-          <a:lstStyle/>
-          <a:p>
-            <a:pPr lvl="0"/>
-            <a:r>
-              <a:rPr lang="en-IN" dirty="0"/>
-              <a:t>Domain: Educational AI &amp; Natural Language Processing </a:t>
-            </a:r>
-          </a:p>
-          <a:p>
-            <a:pPr lvl="0"/>
-            <a:r>
-              <a:rPr lang="en-IN" dirty="0"/>
-              <a:t>Enterprise-Grade Retrieval-Augmented Generation (RAG)</a:t>
-            </a:r>
-          </a:p>
-          <a:p>
-            <a:pPr lvl="0"/>
-            <a:r>
-              <a:rPr lang="en-IN" dirty="0"/>
-              <a:t>Hybrid Search Pipeline combining Semantic Vectors (</a:t>
-            </a:r>
-            <a:r>
-              <a:rPr lang="en-IN" dirty="0" err="1"/>
-              <a:t>ChromaDB</a:t>
-            </a:r>
-            <a:r>
-              <a:rPr lang="en-IN" dirty="0"/>
-              <a:t>) and Lexical Matching (BM25)</a:t>
-            </a:r>
-          </a:p>
-          <a:p>
-            <a:pPr lvl="0"/>
-            <a:r>
-              <a:rPr lang="en-IN" dirty="0"/>
-              <a:t>Real-Time API Orchestration for Current Affairs Aggregation</a:t>
-            </a:r>
-          </a:p>
-          <a:p>
-            <a:pPr lvl="0"/>
-            <a:r>
-              <a:rPr lang="en-IN" dirty="0"/>
-              <a:t>Neural Machine Translation across 12 Regional Indian Languages</a:t>
-            </a:r>
-          </a:p>
-          <a:p>
-            <a:pPr lvl="0"/>
-            <a:r>
-              <a:rPr lang="en-IN" dirty="0"/>
-              <a:t>Interactive Web Application Development </a:t>
-            </a:r>
-          </a:p>
-          <a:p>
-            <a:pPr lvl="0"/>
-            <a:r>
-              <a:rPr lang="en-IN" dirty="0"/>
-              <a:t>CUDA &amp; GPU-Accelerated Computing </a:t>
-            </a:r>
-          </a:p>
-          <a:p>
-            <a:endParaRPr lang="en-IN" dirty="0">
-              <a:latin typeface="Times New Roman" panose="02020603050405020304" pitchFamily="18" charset="0"/>
-              <a:cs typeface="Times New Roman" panose="02020603050405020304" pitchFamily="18" charset="0"/>
-            </a:endParaRPr>
-          </a:p>
-        </p:txBody>
-      </p:sp>
-      <p:sp>
-        <p:nvSpPr>
-          <p:cNvPr id="4" name="Slide Number Placeholder 3"/>
-          <p:cNvSpPr>
-            <a:spLocks noGrp="1"/>
-          </p:cNvSpPr>
-          <p:nvPr>
-            <p:ph type="sldNum" sz="quarter" idx="12"/>
-          </p:nvPr>
-        </p:nvSpPr>
-        <p:spPr/>
-        <p:txBody>
-          <a:bodyPr/>
-          <a:lstStyle/>
-          <a:p>
-            <a:pPr>
-              <a:defRPr/>
-            </a:pPr>
-            <a:fld id="{815EC703-C051-410C-8BA1-62752E291E83}" type="slidenum">
-              <a:rPr lang="en-US" altLang="en-US" smtClean="0"/>
-              <a:t>4</a:t>
-            </a:fld>
-            <a:endParaRPr lang="en-US" altLang="en-US"/>
-          </a:p>
-        </p:txBody>
-      </p:sp>
-    </p:spTree>
-  </p:cSld>
-  <p:clrMapOvr>
-    <a:masterClrMapping/>
-  </p:clrMapOvr>
-</p:sld>
-</file>
-
-<file path=ppt/slides/slide5.xml><?xml version="1.0" encoding="utf-8"?>
-<p:sld xmlns:a="http://schemas.openxmlformats.org/drawingml/2006/main" xmlns:r="http://schemas.openxmlformats.org/officeDocument/2006/relationships" xmlns:p="http://schemas.openxmlformats.org/presentationml/2006/main">
-  <p:cSld>
-    <p:spTree>
-      <p:nvGrpSpPr>
-        <p:cNvPr id="1" name=""/>
-        <p:cNvGrpSpPr/>
-        <p:nvPr/>
-      </p:nvGrpSpPr>
-      <p:grpSpPr>
-        <a:xfrm>
-          <a:off x="0" y="0"/>
-          <a:ext cx="0" cy="0"/>
-          <a:chOff x="0" y="0"/>
-          <a:chExt cx="0" cy="0"/>
-        </a:xfrm>
-      </p:grpSpPr>
-      <p:sp>
-        <p:nvSpPr>
-          <p:cNvPr id="2" name="Title 1"/>
-          <p:cNvSpPr>
-            <a:spLocks noGrp="1"/>
-          </p:cNvSpPr>
-          <p:nvPr>
-            <p:ph type="title"/>
-          </p:nvPr>
-        </p:nvSpPr>
-        <p:spPr>
-          <a:xfrm>
-            <a:off x="838200" y="365125"/>
-            <a:ext cx="10515600" cy="819241"/>
-          </a:xfrm>
-        </p:spPr>
-        <p:txBody>
-          <a:bodyPr/>
-          <a:lstStyle/>
-          <a:p>
-            <a:r>
-              <a:rPr lang="en-IN" sz="3200" b="1" dirty="0">
-                <a:solidFill>
-                  <a:schemeClr val="accent1">
-                    <a:lumMod val="75000"/>
-                  </a:schemeClr>
-                </a:solidFill>
-                <a:latin typeface="Times New Roman" panose="02020603050405020304" pitchFamily="18" charset="0"/>
-                <a:cs typeface="Times New Roman" panose="02020603050405020304" pitchFamily="18" charset="0"/>
-              </a:rPr>
-              <a:t>About your team and reporting Manager</a:t>
-            </a:r>
-          </a:p>
-        </p:txBody>
-      </p:sp>
-      <p:sp>
-        <p:nvSpPr>
-          <p:cNvPr id="3" name="Content Placeholder 2"/>
-          <p:cNvSpPr>
-            <a:spLocks noGrp="1"/>
-          </p:cNvSpPr>
-          <p:nvPr>
-            <p:ph idx="1"/>
-          </p:nvPr>
-        </p:nvSpPr>
-        <p:spPr>
-          <a:xfrm>
-            <a:off x="838200" y="1184367"/>
-            <a:ext cx="10515600" cy="4058194"/>
-          </a:xfrm>
-        </p:spPr>
-        <p:txBody>
-          <a:bodyPr/>
-          <a:lstStyle/>
-          <a:p>
-            <a:pPr lvl="0"/>
-            <a:r>
-              <a:rPr lang="en-IN" dirty="0"/>
-              <a:t>Project: Bharat Study Chatbot – An AI </a:t>
-            </a:r>
-            <a:r>
-              <a:rPr lang="en-IN"/>
-              <a:t>Study Companion</a:t>
-            </a:r>
-            <a:endParaRPr lang="en-IN" dirty="0"/>
-          </a:p>
-          <a:p>
-            <a:pPr lvl="0"/>
-            <a:r>
-              <a:rPr lang="en-IN" dirty="0"/>
-              <a:t>Team Structure: Individual Project - Rohan Blazey </a:t>
-            </a:r>
-          </a:p>
-          <a:p>
-            <a:pPr lvl="0"/>
-            <a:r>
-              <a:rPr lang="en-IN" dirty="0"/>
-              <a:t>Mentorship: NVIDIA AI Centre of Excellence </a:t>
-            </a:r>
-          </a:p>
-          <a:p>
-            <a:pPr lvl="0"/>
-            <a:r>
-              <a:rPr lang="en-IN" dirty="0"/>
-              <a:t>Supervisor: Asst. Prof. John Bennet J</a:t>
-            </a:r>
-          </a:p>
-          <a:p>
-            <a:pPr lvl="0"/>
-            <a:r>
-              <a:rPr lang="en-IN" dirty="0"/>
-              <a:t>Technologies: Next.js, </a:t>
-            </a:r>
-            <a:r>
-              <a:rPr lang="en-IN" dirty="0" err="1"/>
-              <a:t>FastAPI</a:t>
-            </a:r>
-            <a:r>
-              <a:rPr lang="en-IN" dirty="0"/>
-              <a:t>, Python, </a:t>
-            </a:r>
-            <a:r>
-              <a:rPr lang="en-IN" dirty="0" err="1"/>
-              <a:t>ChromaDB</a:t>
-            </a:r>
-            <a:r>
-              <a:rPr lang="en-IN" dirty="0"/>
-              <a:t>, Hugging Face</a:t>
-            </a:r>
-          </a:p>
-          <a:p>
-            <a:pPr lvl="0"/>
-            <a:r>
-              <a:rPr lang="en-IN" dirty="0"/>
-              <a:t>Infrastructure: NVIDIA H200 GPU, Kubernetes</a:t>
-            </a:r>
-          </a:p>
-          <a:p>
-            <a:pPr marL="0" indent="0">
-              <a:buNone/>
-            </a:pPr>
-            <a:endParaRPr lang="en-IN" dirty="0">
-              <a:latin typeface="Times New Roman" panose="02020603050405020304" pitchFamily="18" charset="0"/>
-              <a:cs typeface="Times New Roman" panose="02020603050405020304" pitchFamily="18" charset="0"/>
-            </a:endParaRPr>
-          </a:p>
-        </p:txBody>
-      </p:sp>
-      <p:sp>
-        <p:nvSpPr>
-          <p:cNvPr id="4" name="Slide Number Placeholder 3"/>
-          <p:cNvSpPr>
-            <a:spLocks noGrp="1"/>
-          </p:cNvSpPr>
-          <p:nvPr>
-            <p:ph type="sldNum" sz="quarter" idx="12"/>
-          </p:nvPr>
-        </p:nvSpPr>
-        <p:spPr/>
-        <p:txBody>
-          <a:bodyPr/>
-          <a:lstStyle/>
-          <a:p>
-            <a:pPr>
-              <a:defRPr/>
-            </a:pPr>
-            <a:fld id="{815EC703-C051-410C-8BA1-62752E291E83}" type="slidenum">
-              <a:rPr lang="en-US" altLang="en-US" smtClean="0"/>
-              <a:t>5</a:t>
-            </a:fld>
-            <a:endParaRPr lang="en-US" altLang="en-US"/>
-          </a:p>
-        </p:txBody>
-      </p:sp>
-    </p:spTree>
-  </p:cSld>
-  <p:clrMapOvr>
-    <a:masterClrMapping/>
-  </p:clrMapOvr>
-</p:sld>
-</file>
-
-<file path=ppt/slides/slide6.xml><?xml version="1.0" encoding="utf-8"?>
-<p:sld xmlns:a="http://schemas.openxmlformats.org/drawingml/2006/main" xmlns:r="http://schemas.openxmlformats.org/officeDocument/2006/relationships" xmlns:p="http://schemas.openxmlformats.org/presentationml/2006/main">
-  <p:cSld>
-    <p:spTree>
-      <p:nvGrpSpPr>
-        <p:cNvPr id="1" name=""/>
-        <p:cNvGrpSpPr/>
-        <p:nvPr/>
-      </p:nvGrpSpPr>
-      <p:grpSpPr>
-        <a:xfrm>
-          <a:off x="0" y="0"/>
-          <a:ext cx="0" cy="0"/>
-          <a:chOff x="0" y="0"/>
-          <a:chExt cx="0" cy="0"/>
-        </a:xfrm>
-      </p:grpSpPr>
-      <p:sp>
-        <p:nvSpPr>
-          <p:cNvPr id="2" name="Title 1"/>
-          <p:cNvSpPr>
-            <a:spLocks noGrp="1"/>
-          </p:cNvSpPr>
-          <p:nvPr>
-            <p:ph type="title"/>
-          </p:nvPr>
-        </p:nvSpPr>
-        <p:spPr>
-          <a:xfrm>
-            <a:off x="838200" y="365125"/>
-            <a:ext cx="10515600" cy="819241"/>
-          </a:xfrm>
-        </p:spPr>
-        <p:txBody>
-          <a:bodyPr/>
-          <a:lstStyle/>
-          <a:p>
-            <a:r>
-              <a:rPr lang="en-IN" sz="3200" b="1" dirty="0">
-                <a:solidFill>
-                  <a:schemeClr val="accent1">
-                    <a:lumMod val="75000"/>
-                  </a:schemeClr>
-                </a:solidFill>
-                <a:latin typeface="Times New Roman" panose="02020603050405020304" pitchFamily="18" charset="0"/>
-                <a:cs typeface="Times New Roman" panose="02020603050405020304" pitchFamily="18" charset="0"/>
-              </a:rPr>
-              <a:t>Challenges Faced in Internship</a:t>
-            </a:r>
-          </a:p>
-        </p:txBody>
-      </p:sp>
-      <p:sp>
-        <p:nvSpPr>
-          <p:cNvPr id="3" name="Content Placeholder 2"/>
-          <p:cNvSpPr>
-            <a:spLocks noGrp="1"/>
-          </p:cNvSpPr>
-          <p:nvPr>
-            <p:ph idx="1"/>
-          </p:nvPr>
-        </p:nvSpPr>
-        <p:spPr>
-          <a:xfrm>
-            <a:off x="838200" y="1184367"/>
-            <a:ext cx="10515600" cy="4058194"/>
-          </a:xfrm>
-        </p:spPr>
-        <p:txBody>
-          <a:bodyPr>
-            <a:normAutofit lnSpcReduction="10000"/>
-          </a:bodyPr>
-          <a:lstStyle/>
-          <a:p>
-            <a:pPr lvl="0"/>
-            <a:r>
-              <a:rPr lang="en-IN" dirty="0"/>
-              <a:t>Learning Complex NLP &amp; Transformer Models </a:t>
-            </a:r>
-          </a:p>
-          <a:p>
-            <a:pPr lvl="0"/>
-            <a:r>
-              <a:rPr lang="en-IN" dirty="0"/>
-              <a:t>Mastering CUDA &amp; GPU Computing for AI </a:t>
-            </a:r>
-          </a:p>
-          <a:p>
-            <a:pPr lvl="0"/>
-            <a:r>
-              <a:rPr lang="en-IN" dirty="0"/>
-              <a:t>Understanding Kubernetes Container Orchestration </a:t>
-            </a:r>
-          </a:p>
-          <a:p>
-            <a:pPr lvl="0"/>
-            <a:r>
-              <a:rPr lang="en-IN" dirty="0"/>
-              <a:t>Overcoming the limitations of linear "Naive RAG" pipelines by developing robust Hybrid search algorithms.</a:t>
-            </a:r>
-          </a:p>
-          <a:p>
-            <a:pPr lvl="0"/>
-            <a:r>
-              <a:rPr lang="en-IN" dirty="0"/>
-              <a:t>Resolving silent, cascading API failures caused by environment variable mismatches between local and production deployments.</a:t>
-            </a:r>
-          </a:p>
-          <a:p>
-            <a:pPr lvl="0"/>
-            <a:r>
-              <a:rPr lang="en-IN" dirty="0"/>
-              <a:t>Bypassing rate-limiting bottlenecks from third-party news APIs via redundant failover orchestration.</a:t>
-            </a:r>
-          </a:p>
-          <a:p>
-            <a:endParaRPr lang="en-IN" dirty="0">
-              <a:latin typeface="Times New Roman" panose="02020603050405020304" pitchFamily="18" charset="0"/>
-              <a:cs typeface="Times New Roman" panose="02020603050405020304" pitchFamily="18" charset="0"/>
-            </a:endParaRPr>
-          </a:p>
-        </p:txBody>
-      </p:sp>
-      <p:sp>
-        <p:nvSpPr>
-          <p:cNvPr id="4" name="Slide Number Placeholder 3"/>
-          <p:cNvSpPr>
-            <a:spLocks noGrp="1"/>
-          </p:cNvSpPr>
-          <p:nvPr>
-            <p:ph type="sldNum" sz="quarter" idx="12"/>
-          </p:nvPr>
-        </p:nvSpPr>
-        <p:spPr/>
-        <p:txBody>
-          <a:bodyPr/>
-          <a:lstStyle/>
-          <a:p>
-            <a:pPr>
-              <a:defRPr/>
-            </a:pPr>
-            <a:fld id="{815EC703-C051-410C-8BA1-62752E291E83}" type="slidenum">
-              <a:rPr lang="en-US" altLang="en-US" smtClean="0"/>
-              <a:t>6</a:t>
-            </a:fld>
-            <a:endParaRPr lang="en-US" altLang="en-US"/>
-          </a:p>
-        </p:txBody>
-      </p:sp>
-    </p:spTree>
-  </p:cSld>
-  <p:clrMapOvr>
-    <a:masterClrMapping/>
-  </p:clrMapOvr>
-</p:sld>
-</file>
-
-<file path=ppt/slides/slide7.xml><?xml version="1.0" encoding="utf-8"?>
-<p:sld xmlns:a="http://schemas.openxmlformats.org/drawingml/2006/main" xmlns:r="http://schemas.openxmlformats.org/officeDocument/2006/relationships" xmlns:p="http://schemas.openxmlformats.org/presentationml/2006/main">
-  <p:cSld>
-    <p:spTree>
-      <p:nvGrpSpPr>
-        <p:cNvPr id="1" name=""/>
-        <p:cNvGrpSpPr/>
-        <p:nvPr/>
-      </p:nvGrpSpPr>
-      <p:grpSpPr>
-        <a:xfrm>
-          <a:off x="0" y="0"/>
-          <a:ext cx="0" cy="0"/>
-          <a:chOff x="0" y="0"/>
-          <a:chExt cx="0" cy="0"/>
-        </a:xfrm>
-      </p:grpSpPr>
-      <p:sp>
-        <p:nvSpPr>
-          <p:cNvPr id="2" name="Title 1"/>
-          <p:cNvSpPr>
-            <a:spLocks noGrp="1"/>
-          </p:cNvSpPr>
-          <p:nvPr>
-            <p:ph type="title"/>
-          </p:nvPr>
-        </p:nvSpPr>
-        <p:spPr>
-          <a:xfrm>
-            <a:off x="838200" y="365125"/>
-            <a:ext cx="10515600" cy="819241"/>
-          </a:xfrm>
-        </p:spPr>
-        <p:txBody>
-          <a:bodyPr/>
-          <a:lstStyle/>
-          <a:p>
-            <a:r>
-              <a:rPr lang="en-IN" sz="3200" b="1" dirty="0">
-                <a:solidFill>
-                  <a:schemeClr val="accent1">
-                    <a:lumMod val="75000"/>
-                  </a:schemeClr>
-                </a:solidFill>
-                <a:latin typeface="Times New Roman" panose="02020603050405020304" pitchFamily="18" charset="0"/>
-                <a:cs typeface="Times New Roman" panose="02020603050405020304" pitchFamily="18" charset="0"/>
-              </a:rPr>
-              <a:t>Objectives of the work</a:t>
-            </a:r>
-          </a:p>
-        </p:txBody>
-      </p:sp>
-      <p:sp>
-        <p:nvSpPr>
-          <p:cNvPr id="3" name="Content Placeholder 2"/>
-          <p:cNvSpPr>
-            <a:spLocks noGrp="1"/>
-          </p:cNvSpPr>
-          <p:nvPr>
-            <p:ph idx="1"/>
-          </p:nvPr>
-        </p:nvSpPr>
-        <p:spPr>
-          <a:xfrm>
-            <a:off x="838200" y="1184367"/>
-            <a:ext cx="10515600" cy="4058194"/>
-          </a:xfrm>
-        </p:spPr>
-        <p:txBody>
-          <a:bodyPr>
-            <a:normAutofit fontScale="92500" lnSpcReduction="10000"/>
-          </a:bodyPr>
-          <a:lstStyle/>
-          <a:p>
-            <a:pPr lvl="0"/>
-            <a:r>
-              <a:rPr lang="en-IN" dirty="0"/>
-              <a:t>Automate educational assessment workflows </a:t>
-            </a:r>
-          </a:p>
-          <a:p>
-            <a:pPr lvl="0"/>
-            <a:r>
-              <a:rPr lang="en-IN" dirty="0"/>
-              <a:t>Provide absolute factual determinism by eliminating AI hallucinations in competitive exam preparation (UPSC, NDA, GATE).</a:t>
-            </a:r>
-          </a:p>
-          <a:p>
-            <a:pPr lvl="0"/>
-            <a:r>
-              <a:rPr lang="en-IN" dirty="0"/>
-              <a:t>Ensure computational sovereignty and zero recurring costs by utilizing local, open-source LLMs (Llama-3.2-3.8B).</a:t>
-            </a:r>
-          </a:p>
-          <a:p>
-            <a:pPr lvl="0"/>
-            <a:r>
-              <a:rPr lang="en-IN" dirty="0"/>
-              <a:t>Bridge India's digital and linguistic divide via a low-latency, 12-language localization pipeline.</a:t>
-            </a:r>
-          </a:p>
-          <a:p>
-            <a:pPr lvl="0"/>
-            <a:r>
-              <a:rPr lang="en-IN" dirty="0"/>
-              <a:t>Deploy a universally accessible Progressive Web Application (PWA) to serve resource-constrained mobile hardware in rural demographics.</a:t>
-            </a:r>
-          </a:p>
-          <a:p>
-            <a:pPr lvl="0"/>
-            <a:r>
-              <a:rPr lang="en-IN" dirty="0"/>
-              <a:t>Demonstrate practical AI/ML application in EdTech </a:t>
-            </a:r>
-          </a:p>
-          <a:p>
-            <a:pPr marL="0" indent="0">
-              <a:buNone/>
-            </a:pPr>
-            <a:endParaRPr lang="en-IN" dirty="0">
-              <a:latin typeface="Times New Roman" panose="02020603050405020304" pitchFamily="18" charset="0"/>
-              <a:cs typeface="Times New Roman" panose="02020603050405020304" pitchFamily="18" charset="0"/>
-            </a:endParaRPr>
-          </a:p>
-        </p:txBody>
-      </p:sp>
-      <p:sp>
-        <p:nvSpPr>
-          <p:cNvPr id="4" name="Slide Number Placeholder 3"/>
-          <p:cNvSpPr>
-            <a:spLocks noGrp="1"/>
-          </p:cNvSpPr>
-          <p:nvPr>
-            <p:ph type="sldNum" sz="quarter" idx="12"/>
-          </p:nvPr>
-        </p:nvSpPr>
-        <p:spPr/>
-        <p:txBody>
-          <a:bodyPr/>
-          <a:lstStyle/>
-          <a:p>
-            <a:pPr>
-              <a:defRPr/>
-            </a:pPr>
-            <a:fld id="{815EC703-C051-410C-8BA1-62752E291E83}" type="slidenum">
-              <a:rPr lang="en-US" altLang="en-US" smtClean="0"/>
-              <a:t>7</a:t>
-            </a:fld>
-            <a:endParaRPr lang="en-US" altLang="en-US"/>
-          </a:p>
-        </p:txBody>
-      </p:sp>
-    </p:spTree>
-  </p:cSld>
-  <p:clrMapOvr>
-    <a:masterClrMapping/>
-  </p:clrMapOvr>
-</p:sld>
-</file>
-
-<file path=ppt/slides/slide8.xml><?xml version="1.0" encoding="utf-8"?>
-<p:sld xmlns:a="http://schemas.openxmlformats.org/drawingml/2006/main" xmlns:r="http://schemas.openxmlformats.org/officeDocument/2006/relationships" xmlns:p="http://schemas.openxmlformats.org/presentationml/2006/main">
-  <p:cSld>
-    <p:spTree>
-      <p:nvGrpSpPr>
-        <p:cNvPr id="1" name=""/>
-        <p:cNvGrpSpPr/>
-        <p:nvPr/>
-      </p:nvGrpSpPr>
-      <p:grpSpPr>
-        <a:xfrm>
-          <a:off x="0" y="0"/>
-          <a:ext cx="0" cy="0"/>
-          <a:chOff x="0" y="0"/>
-          <a:chExt cx="0" cy="0"/>
-        </a:xfrm>
-      </p:grpSpPr>
-      <p:sp>
-        <p:nvSpPr>
-          <p:cNvPr id="2" name="Title 1"/>
-          <p:cNvSpPr>
-            <a:spLocks noGrp="1"/>
-          </p:cNvSpPr>
-          <p:nvPr>
-            <p:ph type="title"/>
-          </p:nvPr>
-        </p:nvSpPr>
-        <p:spPr>
-          <a:xfrm>
-            <a:off x="838200" y="365125"/>
-            <a:ext cx="10515600" cy="596311"/>
-          </a:xfrm>
-        </p:spPr>
-        <p:txBody>
-          <a:bodyPr/>
-          <a:lstStyle/>
-          <a:p>
-            <a:r>
-              <a:rPr lang="en-US" sz="3200" b="1" dirty="0">
-                <a:solidFill>
-                  <a:schemeClr val="accent1">
-                    <a:lumMod val="75000"/>
-                  </a:schemeClr>
-                </a:solidFill>
-                <a:latin typeface="Times New Roman" panose="02020603050405020304" pitchFamily="18" charset="0"/>
-                <a:cs typeface="Times New Roman" panose="02020603050405020304" pitchFamily="18" charset="0"/>
-              </a:rPr>
-              <a:t>Github Link</a:t>
-            </a:r>
-          </a:p>
-        </p:txBody>
-      </p:sp>
-      <p:sp>
-        <p:nvSpPr>
-          <p:cNvPr id="4" name="Slide Number Placeholder 3"/>
-          <p:cNvSpPr>
-            <a:spLocks noGrp="1"/>
-          </p:cNvSpPr>
-          <p:nvPr>
-            <p:ph type="sldNum" sz="quarter" idx="12"/>
-          </p:nvPr>
-        </p:nvSpPr>
-        <p:spPr/>
-        <p:txBody>
-          <a:bodyPr/>
-          <a:lstStyle/>
-          <a:p>
-            <a:pPr>
-              <a:defRPr/>
-            </a:pPr>
-            <a:fld id="{815EC703-C051-410C-8BA1-62752E291E83}" type="slidenum">
-              <a:rPr lang="en-US" altLang="en-US" smtClean="0"/>
-              <a:t>8</a:t>
-            </a:fld>
-            <a:endParaRPr lang="en-US" altLang="en-US"/>
-          </a:p>
-        </p:txBody>
-      </p:sp>
-      <p:sp>
-        <p:nvSpPr>
-          <p:cNvPr id="3" name="Content Placeholder 2"/>
-          <p:cNvSpPr>
-            <a:spLocks noGrp="1"/>
-          </p:cNvSpPr>
-          <p:nvPr>
-            <p:ph idx="1"/>
-          </p:nvPr>
-        </p:nvSpPr>
-        <p:spPr>
-          <a:xfrm>
-            <a:off x="446308" y="1061297"/>
-            <a:ext cx="10515600" cy="4351338"/>
-          </a:xfrm>
-        </p:spPr>
-        <p:txBody>
-          <a:bodyPr/>
-          <a:lstStyle/>
-          <a:p>
-            <a:r>
-              <a:rPr lang="en-US" altLang="en-US" dirty="0"/>
-              <a:t>https://github.com/ROHAN-BLAZEY/bharat-study-chatbot</a:t>
-            </a:r>
-          </a:p>
-        </p:txBody>
-      </p:sp>
-    </p:spTree>
-  </p:cSld>
-  <p:clrMapOvr>
-    <a:masterClrMapping/>
-  </p:clrMapOvr>
-</p:sld>
-</file>
-
-<file path=ppt/slides/slide9.xml><?xml version="1.0" encoding="utf-8"?>
-<p:sld xmlns:a="http://schemas.openxmlformats.org/drawingml/2006/main" xmlns:r="http://schemas.openxmlformats.org/officeDocument/2006/relationships" xmlns:p="http://schemas.openxmlformats.org/presentationml/2006/main">
-  <p:cSld>
-    <p:spTree>
-      <p:nvGrpSpPr>
-        <p:cNvPr id="1" name=""/>
-        <p:cNvGrpSpPr/>
-        <p:nvPr/>
-      </p:nvGrpSpPr>
-      <p:grpSpPr>
-        <a:xfrm>
-          <a:off x="0" y="0"/>
-          <a:ext cx="0" cy="0"/>
-          <a:chOff x="0" y="0"/>
-          <a:chExt cx="0" cy="0"/>
-        </a:xfrm>
-      </p:grpSpPr>
-      <p:sp>
-        <p:nvSpPr>
-          <p:cNvPr id="3" name="Content Placeholder 2"/>
-          <p:cNvSpPr>
-            <a:spLocks noGrp="1"/>
-          </p:cNvSpPr>
-          <p:nvPr>
-            <p:ph idx="1"/>
-          </p:nvPr>
-        </p:nvSpPr>
-        <p:spPr>
-          <a:xfrm>
             <a:off x="0" y="0"/>
             <a:ext cx="12192000" cy="6858000"/>
           </a:xfrm>
@@ -6042,7 +4675,7 @@
                 <a:latin typeface="Times New Roman" panose="02020603050405020304" pitchFamily="18" charset="0"/>
                 <a:cs typeface="Times New Roman" panose="02020603050405020304" pitchFamily="18" charset="0"/>
               </a:rPr>
-              <a:t>9</a:t>
+              <a:t>10</a:t>
             </a:fld>
             <a:endParaRPr lang="en-US" altLang="en-US">
               <a:latin typeface="Times New Roman" panose="02020603050405020304" pitchFamily="18" charset="0"/>
@@ -6105,6 +4738,1662 @@
           </a:extLst>
         </p:spPr>
       </p:pic>
+    </p:spTree>
+  </p:cSld>
+  <p:clrMapOvr>
+    <a:masterClrMapping/>
+  </p:clrMapOvr>
+</p:sld>
+</file>
+
+<file path=ppt/slides/slide11.xml><?xml version="1.0" encoding="utf-8"?>
+<p:sld xmlns:a="http://schemas.openxmlformats.org/drawingml/2006/main" xmlns:r="http://schemas.openxmlformats.org/officeDocument/2006/relationships" xmlns:p="http://schemas.openxmlformats.org/presentationml/2006/main">
+  <p:cSld>
+    <p:spTree>
+      <p:nvGrpSpPr>
+        <p:cNvPr id="1" name=""/>
+        <p:cNvGrpSpPr/>
+        <p:nvPr/>
+      </p:nvGrpSpPr>
+      <p:grpSpPr>
+        <a:xfrm>
+          <a:off x="0" y="0"/>
+          <a:ext cx="0" cy="0"/>
+          <a:chOff x="0" y="0"/>
+          <a:chExt cx="0" cy="0"/>
+        </a:xfrm>
+      </p:grpSpPr>
+      <p:sp>
+        <p:nvSpPr>
+          <p:cNvPr id="3" name="Content Placeholder 2"/>
+          <p:cNvSpPr>
+            <a:spLocks noGrp="1"/>
+          </p:cNvSpPr>
+          <p:nvPr>
+            <p:ph idx="1"/>
+          </p:nvPr>
+        </p:nvSpPr>
+        <p:spPr>
+          <a:xfrm>
+            <a:off x="838200" y="2547258"/>
+            <a:ext cx="10515600" cy="1214846"/>
+          </a:xfrm>
+        </p:spPr>
+        <p:txBody>
+          <a:bodyPr/>
+          <a:lstStyle/>
+          <a:p>
+            <a:pPr marL="0" indent="0" algn="ctr">
+              <a:buNone/>
+            </a:pPr>
+            <a:r>
+              <a:rPr lang="en-US" sz="6600" dirty="0">
+                <a:solidFill>
+                  <a:srgbClr val="A71180"/>
+                </a:solidFill>
+                <a:latin typeface="Times New Roman" panose="02020603050405020304" pitchFamily="18" charset="0"/>
+                <a:cs typeface="Times New Roman" panose="02020603050405020304" pitchFamily="18" charset="0"/>
+              </a:rPr>
+              <a:t>Thank you !!</a:t>
+            </a:r>
+          </a:p>
+        </p:txBody>
+      </p:sp>
+      <p:sp>
+        <p:nvSpPr>
+          <p:cNvPr id="4" name="Slide Number Placeholder 3"/>
+          <p:cNvSpPr>
+            <a:spLocks noGrp="1"/>
+          </p:cNvSpPr>
+          <p:nvPr>
+            <p:ph type="sldNum" sz="quarter" idx="12"/>
+          </p:nvPr>
+        </p:nvSpPr>
+        <p:spPr/>
+        <p:txBody>
+          <a:bodyPr/>
+          <a:lstStyle/>
+          <a:p>
+            <a:pPr>
+              <a:defRPr/>
+            </a:pPr>
+            <a:fld id="{815EC703-C051-410C-8BA1-62752E291E83}" type="slidenum">
+              <a:rPr lang="en-US" altLang="en-US" smtClean="0"/>
+              <a:t>11</a:t>
+            </a:fld>
+            <a:endParaRPr lang="en-US" altLang="en-US"/>
+          </a:p>
+        </p:txBody>
+      </p:sp>
+    </p:spTree>
+  </p:cSld>
+  <p:clrMapOvr>
+    <a:masterClrMapping/>
+  </p:clrMapOvr>
+</p:sld>
+</file>
+
+<file path=ppt/slides/slide2.xml><?xml version="1.0" encoding="utf-8"?>
+<p:sld xmlns:a="http://schemas.openxmlformats.org/drawingml/2006/main" xmlns:r="http://schemas.openxmlformats.org/officeDocument/2006/relationships" xmlns:p="http://schemas.openxmlformats.org/presentationml/2006/main">
+  <p:cSld>
+    <p:spTree>
+      <p:nvGrpSpPr>
+        <p:cNvPr id="1" name="Shape 95"/>
+        <p:cNvGrpSpPr/>
+        <p:nvPr/>
+      </p:nvGrpSpPr>
+      <p:grpSpPr>
+        <a:xfrm>
+          <a:off x="0" y="0"/>
+          <a:ext cx="0" cy="0"/>
+          <a:chOff x="0" y="0"/>
+          <a:chExt cx="0" cy="0"/>
+        </a:xfrm>
+      </p:grpSpPr>
+      <p:sp>
+        <p:nvSpPr>
+          <p:cNvPr id="96" name="Google Shape;96;p14"/>
+          <p:cNvSpPr txBox="1">
+            <a:spLocks noGrp="1"/>
+          </p:cNvSpPr>
+          <p:nvPr>
+            <p:ph type="title"/>
+          </p:nvPr>
+        </p:nvSpPr>
+        <p:spPr>
+          <a:xfrm>
+            <a:off x="812800" y="274638"/>
+            <a:ext cx="10668000" cy="487500"/>
+          </a:xfrm>
+          <a:prstGeom prst="rect">
+            <a:avLst/>
+          </a:prstGeom>
+          <a:noFill/>
+          <a:ln>
+            <a:noFill/>
+          </a:ln>
+        </p:spPr>
+        <p:txBody>
+          <a:bodyPr spcFirstLastPara="1" wrap="square" lIns="91425" tIns="45700" rIns="91425" bIns="45700" anchor="ctr" anchorCtr="0">
+            <a:noAutofit/>
+          </a:bodyPr>
+          <a:lstStyle/>
+          <a:p>
+            <a:pPr marL="0" lvl="0" indent="0" algn="l" rtl="0">
+              <a:spcBef>
+                <a:spcPts val="0"/>
+              </a:spcBef>
+              <a:spcAft>
+                <a:spcPts val="0"/>
+              </a:spcAft>
+              <a:buClr>
+                <a:srgbClr val="17365D"/>
+              </a:buClr>
+              <a:buSzPts val="2800"/>
+              <a:buFont typeface="Verdana" panose="020B0604030504040204"/>
+              <a:buNone/>
+            </a:pPr>
+            <a:r>
+              <a:rPr lang="en-GB" dirty="0">
+                <a:latin typeface="Cambria" panose="02040503050406030204" pitchFamily="18" charset="0"/>
+                <a:ea typeface="Cambria" panose="02040503050406030204" pitchFamily="18" charset="0"/>
+              </a:rPr>
+              <a:t>Content</a:t>
+            </a:r>
+            <a:endParaRPr dirty="0">
+              <a:latin typeface="Cambria" panose="02040503050406030204" pitchFamily="18" charset="0"/>
+              <a:ea typeface="Cambria" panose="02040503050406030204" pitchFamily="18" charset="0"/>
+            </a:endParaRPr>
+          </a:p>
+        </p:txBody>
+      </p:sp>
+      <p:sp>
+        <p:nvSpPr>
+          <p:cNvPr id="97" name="Google Shape;97;p14"/>
+          <p:cNvSpPr txBox="1">
+            <a:spLocks noGrp="1"/>
+          </p:cNvSpPr>
+          <p:nvPr>
+            <p:ph type="body" idx="1"/>
+          </p:nvPr>
+        </p:nvSpPr>
+        <p:spPr>
+          <a:xfrm>
+            <a:off x="704516" y="902370"/>
+            <a:ext cx="10668000" cy="4271209"/>
+          </a:xfrm>
+          <a:prstGeom prst="rect">
+            <a:avLst/>
+          </a:prstGeom>
+          <a:noFill/>
+          <a:ln>
+            <a:noFill/>
+          </a:ln>
+        </p:spPr>
+        <p:txBody>
+          <a:bodyPr spcFirstLastPara="1" wrap="square" lIns="91425" tIns="45700" rIns="91425" bIns="45700" anchor="t" anchorCtr="0">
+            <a:noAutofit/>
+          </a:bodyPr>
+          <a:lstStyle/>
+          <a:p>
+            <a:pPr marL="495300" indent="-342900" algn="just">
+              <a:lnSpc>
+                <a:spcPct val="200000"/>
+              </a:lnSpc>
+              <a:spcBef>
+                <a:spcPts val="0"/>
+              </a:spcBef>
+              <a:buFont typeface="Wingdings" panose="05000000000000000000" pitchFamily="2" charset="2"/>
+              <a:buChar char="Ø"/>
+            </a:pPr>
+            <a:r>
+              <a:rPr lang="en-US" sz="2000" b="1" dirty="0">
+                <a:solidFill>
+                  <a:schemeClr val="accent1">
+                    <a:lumMod val="75000"/>
+                  </a:schemeClr>
+                </a:solidFill>
+                <a:latin typeface="Times New Roman" panose="02020603050405020304" pitchFamily="18" charset="0"/>
+                <a:cs typeface="Times New Roman" panose="02020603050405020304" pitchFamily="18" charset="0"/>
+              </a:rPr>
+              <a:t>About Company or Organization</a:t>
+            </a:r>
+          </a:p>
+          <a:p>
+            <a:pPr marL="495300" indent="-342900" algn="just">
+              <a:lnSpc>
+                <a:spcPct val="200000"/>
+              </a:lnSpc>
+              <a:spcBef>
+                <a:spcPts val="0"/>
+              </a:spcBef>
+              <a:buFont typeface="Wingdings" panose="05000000000000000000" pitchFamily="2" charset="2"/>
+              <a:buChar char="Ø"/>
+            </a:pPr>
+            <a:r>
+              <a:rPr lang="en-IN" sz="2000" b="1" dirty="0">
+                <a:solidFill>
+                  <a:schemeClr val="accent1">
+                    <a:lumMod val="75000"/>
+                  </a:schemeClr>
+                </a:solidFill>
+                <a:latin typeface="Times New Roman" panose="02020603050405020304" pitchFamily="18" charset="0"/>
+                <a:cs typeface="Times New Roman" panose="02020603050405020304" pitchFamily="18" charset="0"/>
+              </a:rPr>
+              <a:t>Working domain or the technology</a:t>
+            </a:r>
+            <a:endParaRPr lang="en-US" sz="2000" dirty="0">
+              <a:solidFill>
+                <a:schemeClr val="accent1">
+                  <a:lumMod val="75000"/>
+                </a:schemeClr>
+              </a:solidFill>
+              <a:latin typeface="Cambria" panose="02040503050406030204" pitchFamily="18" charset="0"/>
+              <a:ea typeface="Cambria" panose="02040503050406030204" pitchFamily="18" charset="0"/>
+            </a:endParaRPr>
+          </a:p>
+          <a:p>
+            <a:pPr marL="495300" indent="-342900" algn="just">
+              <a:lnSpc>
+                <a:spcPct val="200000"/>
+              </a:lnSpc>
+              <a:spcBef>
+                <a:spcPts val="0"/>
+              </a:spcBef>
+              <a:buFont typeface="Wingdings" panose="05000000000000000000" pitchFamily="2" charset="2"/>
+              <a:buChar char="Ø"/>
+            </a:pPr>
+            <a:r>
+              <a:rPr lang="en-IN" sz="2000" b="1" dirty="0">
+                <a:solidFill>
+                  <a:schemeClr val="accent1">
+                    <a:lumMod val="75000"/>
+                  </a:schemeClr>
+                </a:solidFill>
+                <a:latin typeface="Times New Roman" panose="02020603050405020304" pitchFamily="18" charset="0"/>
+                <a:cs typeface="Times New Roman" panose="02020603050405020304" pitchFamily="18" charset="0"/>
+              </a:rPr>
+              <a:t>About your team and reporting Manager</a:t>
+            </a:r>
+            <a:endParaRPr lang="en-US" sz="2000" dirty="0">
+              <a:solidFill>
+                <a:schemeClr val="accent1">
+                  <a:lumMod val="75000"/>
+                </a:schemeClr>
+              </a:solidFill>
+              <a:latin typeface="Cambria" panose="02040503050406030204" pitchFamily="18" charset="0"/>
+              <a:ea typeface="Cambria" panose="02040503050406030204" pitchFamily="18" charset="0"/>
+            </a:endParaRPr>
+          </a:p>
+          <a:p>
+            <a:pPr marL="495300" indent="-342900" algn="just">
+              <a:lnSpc>
+                <a:spcPct val="200000"/>
+              </a:lnSpc>
+              <a:spcBef>
+                <a:spcPts val="0"/>
+              </a:spcBef>
+              <a:buFont typeface="Wingdings" panose="05000000000000000000" pitchFamily="2" charset="2"/>
+              <a:buChar char="Ø"/>
+            </a:pPr>
+            <a:r>
+              <a:rPr lang="en-IN" sz="2000" b="1" dirty="0">
+                <a:solidFill>
+                  <a:schemeClr val="accent1">
+                    <a:lumMod val="75000"/>
+                  </a:schemeClr>
+                </a:solidFill>
+                <a:latin typeface="Times New Roman" panose="02020603050405020304" pitchFamily="18" charset="0"/>
+                <a:cs typeface="Times New Roman" panose="02020603050405020304" pitchFamily="18" charset="0"/>
+              </a:rPr>
+              <a:t>Challenges Faced in Internship</a:t>
+            </a:r>
+            <a:endParaRPr lang="en-US" sz="2000" dirty="0">
+              <a:solidFill>
+                <a:schemeClr val="accent1">
+                  <a:lumMod val="75000"/>
+                </a:schemeClr>
+              </a:solidFill>
+              <a:latin typeface="Cambria" panose="02040503050406030204" pitchFamily="18" charset="0"/>
+              <a:ea typeface="Cambria" panose="02040503050406030204" pitchFamily="18" charset="0"/>
+            </a:endParaRPr>
+          </a:p>
+          <a:p>
+            <a:pPr marL="495300" indent="-342900" algn="just">
+              <a:lnSpc>
+                <a:spcPct val="200000"/>
+              </a:lnSpc>
+              <a:spcBef>
+                <a:spcPts val="0"/>
+              </a:spcBef>
+              <a:buFont typeface="Wingdings" panose="05000000000000000000" pitchFamily="2" charset="2"/>
+              <a:buChar char="Ø"/>
+            </a:pPr>
+            <a:r>
+              <a:rPr lang="en-IN" sz="2000" b="1" dirty="0">
+                <a:solidFill>
+                  <a:schemeClr val="accent1">
+                    <a:lumMod val="75000"/>
+                  </a:schemeClr>
+                </a:solidFill>
+                <a:latin typeface="Times New Roman" panose="02020603050405020304" pitchFamily="18" charset="0"/>
+                <a:cs typeface="Times New Roman" panose="02020603050405020304" pitchFamily="18" charset="0"/>
+              </a:rPr>
+              <a:t>Objectives of the work</a:t>
+            </a:r>
+          </a:p>
+          <a:p>
+            <a:pPr marL="495300" indent="-342900" algn="just">
+              <a:lnSpc>
+                <a:spcPct val="200000"/>
+              </a:lnSpc>
+              <a:spcBef>
+                <a:spcPts val="0"/>
+              </a:spcBef>
+              <a:buFont typeface="Wingdings" panose="05000000000000000000" pitchFamily="2" charset="2"/>
+              <a:buChar char="Ø"/>
+            </a:pPr>
+            <a:r>
+              <a:rPr lang="en-IN" sz="2000" b="1" dirty="0">
+                <a:solidFill>
+                  <a:schemeClr val="accent1">
+                    <a:lumMod val="75000"/>
+                  </a:schemeClr>
+                </a:solidFill>
+                <a:latin typeface="Times New Roman" panose="02020603050405020304" pitchFamily="18" charset="0"/>
+                <a:cs typeface="Times New Roman" panose="02020603050405020304" pitchFamily="18" charset="0"/>
+              </a:rPr>
+              <a:t>Internship Roadmap</a:t>
+            </a:r>
+          </a:p>
+          <a:p>
+            <a:pPr marL="495300" indent="-342900" algn="just">
+              <a:lnSpc>
+                <a:spcPct val="200000"/>
+              </a:lnSpc>
+              <a:spcBef>
+                <a:spcPts val="0"/>
+              </a:spcBef>
+              <a:buFont typeface="Wingdings" panose="05000000000000000000" pitchFamily="2" charset="2"/>
+              <a:buChar char="Ø"/>
+            </a:pPr>
+            <a:r>
+              <a:rPr lang="en-IN" sz="2000" b="1" dirty="0">
+                <a:solidFill>
+                  <a:schemeClr val="accent1">
+                    <a:lumMod val="75000"/>
+                  </a:schemeClr>
+                </a:solidFill>
+                <a:latin typeface="Times New Roman" panose="02020603050405020304" pitchFamily="18" charset="0"/>
+                <a:cs typeface="Times New Roman" panose="02020603050405020304" pitchFamily="18" charset="0"/>
+              </a:rPr>
+              <a:t>Github Link</a:t>
+            </a:r>
+            <a:endParaRPr lang="en-US" sz="2000" dirty="0">
+              <a:solidFill>
+                <a:schemeClr val="accent1">
+                  <a:lumMod val="75000"/>
+                </a:schemeClr>
+              </a:solidFill>
+              <a:latin typeface="Cambria" panose="02040503050406030204" pitchFamily="18" charset="0"/>
+              <a:ea typeface="Cambria" panose="02040503050406030204" pitchFamily="18" charset="0"/>
+            </a:endParaRPr>
+          </a:p>
+          <a:p>
+            <a:pPr marL="495300" lvl="0" indent="-342900" algn="just" rtl="0">
+              <a:lnSpc>
+                <a:spcPct val="200000"/>
+              </a:lnSpc>
+              <a:spcBef>
+                <a:spcPts val="0"/>
+              </a:spcBef>
+              <a:spcAft>
+                <a:spcPts val="0"/>
+              </a:spcAft>
+              <a:buClr>
+                <a:schemeClr val="dk1"/>
+              </a:buClr>
+              <a:buSzPts val="2400"/>
+              <a:buFont typeface="Wingdings" panose="05000000000000000000" pitchFamily="2" charset="2"/>
+              <a:buChar char="Ø"/>
+            </a:pPr>
+            <a:endParaRPr lang="en-US" sz="2000" dirty="0">
+              <a:solidFill>
+                <a:schemeClr val="accent1">
+                  <a:lumMod val="75000"/>
+                </a:schemeClr>
+              </a:solidFill>
+              <a:latin typeface="Cambria" panose="02040503050406030204" pitchFamily="18" charset="0"/>
+              <a:ea typeface="Cambria" panose="02040503050406030204" pitchFamily="18" charset="0"/>
+            </a:endParaRPr>
+          </a:p>
+        </p:txBody>
+      </p:sp>
+    </p:spTree>
+  </p:cSld>
+  <p:clrMapOvr>
+    <a:masterClrMapping/>
+  </p:clrMapOvr>
+</p:sld>
+</file>
+
+<file path=ppt/slides/slide3.xml><?xml version="1.0" encoding="utf-8"?>
+<p:sld xmlns:a="http://schemas.openxmlformats.org/drawingml/2006/main" xmlns:r="http://schemas.openxmlformats.org/officeDocument/2006/relationships" xmlns:p="http://schemas.openxmlformats.org/presentationml/2006/main">
+  <p:cSld>
+    <p:spTree>
+      <p:nvGrpSpPr>
+        <p:cNvPr id="1" name=""/>
+        <p:cNvGrpSpPr/>
+        <p:nvPr/>
+      </p:nvGrpSpPr>
+      <p:grpSpPr>
+        <a:xfrm>
+          <a:off x="0" y="0"/>
+          <a:ext cx="0" cy="0"/>
+          <a:chOff x="0" y="0"/>
+          <a:chExt cx="0" cy="0"/>
+        </a:xfrm>
+      </p:grpSpPr>
+      <p:sp>
+        <p:nvSpPr>
+          <p:cNvPr id="2" name="Title 1"/>
+          <p:cNvSpPr>
+            <a:spLocks noGrp="1"/>
+          </p:cNvSpPr>
+          <p:nvPr>
+            <p:ph type="title"/>
+          </p:nvPr>
+        </p:nvSpPr>
+        <p:spPr>
+          <a:xfrm>
+            <a:off x="838200" y="365125"/>
+            <a:ext cx="10515600" cy="819241"/>
+          </a:xfrm>
+        </p:spPr>
+        <p:txBody>
+          <a:bodyPr/>
+          <a:lstStyle/>
+          <a:p>
+            <a:r>
+              <a:rPr lang="en-US" sz="3200" b="1" dirty="0">
+                <a:solidFill>
+                  <a:schemeClr val="accent1">
+                    <a:lumMod val="75000"/>
+                  </a:schemeClr>
+                </a:solidFill>
+                <a:latin typeface="Times New Roman" panose="02020603050405020304" pitchFamily="18" charset="0"/>
+                <a:cs typeface="Times New Roman" panose="02020603050405020304" pitchFamily="18" charset="0"/>
+              </a:rPr>
+              <a:t>O</a:t>
+            </a:r>
+            <a:r>
+              <a:rPr lang="en-IN" sz="3200" b="1" dirty="0" err="1">
+                <a:solidFill>
+                  <a:schemeClr val="accent1">
+                    <a:lumMod val="75000"/>
+                  </a:schemeClr>
+                </a:solidFill>
+                <a:latin typeface="Times New Roman" panose="02020603050405020304" pitchFamily="18" charset="0"/>
+                <a:cs typeface="Times New Roman" panose="02020603050405020304" pitchFamily="18" charset="0"/>
+              </a:rPr>
+              <a:t>verview</a:t>
+            </a:r>
+            <a:endParaRPr lang="en-IN" sz="3200" b="1" dirty="0">
+              <a:solidFill>
+                <a:schemeClr val="accent1">
+                  <a:lumMod val="75000"/>
+                </a:schemeClr>
+              </a:solidFill>
+              <a:latin typeface="Times New Roman" panose="02020603050405020304" pitchFamily="18" charset="0"/>
+              <a:cs typeface="Times New Roman" panose="02020603050405020304" pitchFamily="18" charset="0"/>
+            </a:endParaRPr>
+          </a:p>
+        </p:txBody>
+      </p:sp>
+      <p:sp>
+        <p:nvSpPr>
+          <p:cNvPr id="3" name="Content Placeholder 2"/>
+          <p:cNvSpPr>
+            <a:spLocks noGrp="1"/>
+          </p:cNvSpPr>
+          <p:nvPr>
+            <p:ph idx="1"/>
+          </p:nvPr>
+        </p:nvSpPr>
+        <p:spPr>
+          <a:xfrm>
+            <a:off x="838200" y="1184367"/>
+            <a:ext cx="10515600" cy="4058194"/>
+          </a:xfrm>
+        </p:spPr>
+        <p:txBody>
+          <a:bodyPr>
+            <a:normAutofit/>
+          </a:bodyPr>
+          <a:lstStyle/>
+          <a:p>
+            <a:pPr lvl="0"/>
+            <a:r>
+              <a:rPr lang="en-IN" dirty="0"/>
+              <a:t>Project: Bharat Study Chatbot – An AI Study Companion</a:t>
+            </a:r>
+          </a:p>
+          <a:p>
+            <a:pPr lvl="0"/>
+            <a:r>
+              <a:rPr lang="en-IN" dirty="0"/>
+              <a:t>Team Structure: Individual Project - Rohan Blazey </a:t>
+            </a:r>
+          </a:p>
+          <a:p>
+            <a:pPr lvl="0"/>
+            <a:r>
+              <a:rPr lang="en-IN" dirty="0"/>
+              <a:t>Mentorship: NVIDIA AI Centre of Excellence </a:t>
+            </a:r>
+          </a:p>
+          <a:p>
+            <a:pPr lvl="0"/>
+            <a:r>
+              <a:rPr lang="en-IN" dirty="0"/>
+              <a:t>Supervisor: Asst. Prof. John Bennet J</a:t>
+            </a:r>
+          </a:p>
+          <a:p>
+            <a:pPr lvl="0"/>
+            <a:r>
+              <a:rPr lang="en-IN" dirty="0"/>
+              <a:t>Technologies: Next.js, </a:t>
+            </a:r>
+            <a:r>
+              <a:rPr lang="en-IN" dirty="0" err="1"/>
+              <a:t>FastAPI</a:t>
+            </a:r>
+            <a:r>
+              <a:rPr lang="en-IN" dirty="0"/>
+              <a:t>, Python, </a:t>
+            </a:r>
+            <a:r>
+              <a:rPr lang="en-IN" dirty="0" err="1"/>
+              <a:t>ChromaDB</a:t>
+            </a:r>
+            <a:r>
+              <a:rPr lang="en-IN" dirty="0"/>
+              <a:t>, Hugging Face</a:t>
+            </a:r>
+          </a:p>
+          <a:p>
+            <a:pPr lvl="0"/>
+            <a:r>
+              <a:rPr lang="en-IN" dirty="0"/>
+              <a:t>Infrastructure: The infrastructure operates as a zero-cost Edge AI system running entirely on a local laptop CPU and Wi-Fi network, with cross-device accessibility</a:t>
+            </a:r>
+            <a:endParaRPr lang="en-IN" dirty="0">
+              <a:latin typeface="Times New Roman" panose="02020603050405020304" pitchFamily="18" charset="0"/>
+              <a:cs typeface="Times New Roman" panose="02020603050405020304" pitchFamily="18" charset="0"/>
+            </a:endParaRPr>
+          </a:p>
+        </p:txBody>
+      </p:sp>
+      <p:sp>
+        <p:nvSpPr>
+          <p:cNvPr id="4" name="Slide Number Placeholder 3"/>
+          <p:cNvSpPr>
+            <a:spLocks noGrp="1"/>
+          </p:cNvSpPr>
+          <p:nvPr>
+            <p:ph type="sldNum" sz="quarter" idx="12"/>
+          </p:nvPr>
+        </p:nvSpPr>
+        <p:spPr/>
+        <p:txBody>
+          <a:bodyPr/>
+          <a:lstStyle/>
+          <a:p>
+            <a:pPr>
+              <a:defRPr/>
+            </a:pPr>
+            <a:fld id="{815EC703-C051-410C-8BA1-62752E291E83}" type="slidenum">
+              <a:rPr lang="en-US" altLang="en-US" smtClean="0"/>
+              <a:t>3</a:t>
+            </a:fld>
+            <a:endParaRPr lang="en-US" altLang="en-US"/>
+          </a:p>
+        </p:txBody>
+      </p:sp>
+    </p:spTree>
+  </p:cSld>
+  <p:clrMapOvr>
+    <a:masterClrMapping/>
+  </p:clrMapOvr>
+</p:sld>
+</file>
+
+<file path=ppt/slides/slide4.xml><?xml version="1.0" encoding="utf-8"?>
+<p:sld xmlns:a="http://schemas.openxmlformats.org/drawingml/2006/main" xmlns:r="http://schemas.openxmlformats.org/officeDocument/2006/relationships" xmlns:p="http://schemas.openxmlformats.org/presentationml/2006/main">
+  <p:cSld>
+    <p:spTree>
+      <p:nvGrpSpPr>
+        <p:cNvPr id="1" name=""/>
+        <p:cNvGrpSpPr/>
+        <p:nvPr/>
+      </p:nvGrpSpPr>
+      <p:grpSpPr>
+        <a:xfrm>
+          <a:off x="0" y="0"/>
+          <a:ext cx="0" cy="0"/>
+          <a:chOff x="0" y="0"/>
+          <a:chExt cx="0" cy="0"/>
+        </a:xfrm>
+      </p:grpSpPr>
+      <p:sp>
+        <p:nvSpPr>
+          <p:cNvPr id="2" name="Title 1"/>
+          <p:cNvSpPr>
+            <a:spLocks noGrp="1"/>
+          </p:cNvSpPr>
+          <p:nvPr>
+            <p:ph type="title"/>
+          </p:nvPr>
+        </p:nvSpPr>
+        <p:spPr>
+          <a:xfrm>
+            <a:off x="838200" y="365125"/>
+            <a:ext cx="10515600" cy="819241"/>
+          </a:xfrm>
+        </p:spPr>
+        <p:txBody>
+          <a:bodyPr/>
+          <a:lstStyle/>
+          <a:p>
+            <a:r>
+              <a:rPr lang="en-IN" sz="3200" b="1" dirty="0">
+                <a:solidFill>
+                  <a:schemeClr val="accent1">
+                    <a:lumMod val="75000"/>
+                  </a:schemeClr>
+                </a:solidFill>
+                <a:latin typeface="Times New Roman" panose="02020603050405020304" pitchFamily="18" charset="0"/>
+                <a:cs typeface="Times New Roman" panose="02020603050405020304" pitchFamily="18" charset="0"/>
+              </a:rPr>
+              <a:t>Objectives of the work</a:t>
+            </a:r>
+          </a:p>
+        </p:txBody>
+      </p:sp>
+      <p:sp>
+        <p:nvSpPr>
+          <p:cNvPr id="3" name="Content Placeholder 2"/>
+          <p:cNvSpPr>
+            <a:spLocks noGrp="1"/>
+          </p:cNvSpPr>
+          <p:nvPr>
+            <p:ph idx="1"/>
+          </p:nvPr>
+        </p:nvSpPr>
+        <p:spPr>
+          <a:xfrm>
+            <a:off x="838200" y="1184367"/>
+            <a:ext cx="10515600" cy="4058194"/>
+          </a:xfrm>
+        </p:spPr>
+        <p:txBody>
+          <a:bodyPr>
+            <a:normAutofit fontScale="92500" lnSpcReduction="10000"/>
+          </a:bodyPr>
+          <a:lstStyle/>
+          <a:p>
+            <a:pPr lvl="0"/>
+            <a:r>
+              <a:rPr lang="en-IN" dirty="0"/>
+              <a:t>Automate educational assessment workflows </a:t>
+            </a:r>
+          </a:p>
+          <a:p>
+            <a:pPr lvl="0"/>
+            <a:r>
+              <a:rPr lang="en-IN" dirty="0"/>
+              <a:t>Provide absolute factual determinism by eliminating AI hallucinations in competitive exam preparation (UPSC, NDA, GATE).</a:t>
+            </a:r>
+          </a:p>
+          <a:p>
+            <a:pPr lvl="0"/>
+            <a:r>
+              <a:rPr lang="en-IN" dirty="0"/>
+              <a:t>Ensure computational sovereignty and zero recurring costs by utilizing local, open-source LLMs (Llama-3.2-3.8B).</a:t>
+            </a:r>
+          </a:p>
+          <a:p>
+            <a:pPr lvl="0"/>
+            <a:r>
+              <a:rPr lang="en-IN" dirty="0"/>
+              <a:t>Bridge India's digital and linguistic divide via a low-latency, 12-language localization pipeline.</a:t>
+            </a:r>
+          </a:p>
+          <a:p>
+            <a:pPr lvl="0"/>
+            <a:r>
+              <a:rPr lang="en-IN" dirty="0"/>
+              <a:t>Deploy a universally accessible Progressive Web Application (PWA) to serve resource-constrained mobile hardware in rural demographics.</a:t>
+            </a:r>
+          </a:p>
+          <a:p>
+            <a:pPr lvl="0"/>
+            <a:r>
+              <a:rPr lang="en-IN" dirty="0"/>
+              <a:t>Demonstrate practical AI/ML application in EdTech </a:t>
+            </a:r>
+          </a:p>
+          <a:p>
+            <a:pPr marL="0" indent="0">
+              <a:buNone/>
+            </a:pPr>
+            <a:endParaRPr lang="en-IN" dirty="0">
+              <a:latin typeface="Times New Roman" panose="02020603050405020304" pitchFamily="18" charset="0"/>
+              <a:cs typeface="Times New Roman" panose="02020603050405020304" pitchFamily="18" charset="0"/>
+            </a:endParaRPr>
+          </a:p>
+        </p:txBody>
+      </p:sp>
+      <p:sp>
+        <p:nvSpPr>
+          <p:cNvPr id="4" name="Slide Number Placeholder 3"/>
+          <p:cNvSpPr>
+            <a:spLocks noGrp="1"/>
+          </p:cNvSpPr>
+          <p:nvPr>
+            <p:ph type="sldNum" sz="quarter" idx="12"/>
+          </p:nvPr>
+        </p:nvSpPr>
+        <p:spPr/>
+        <p:txBody>
+          <a:bodyPr/>
+          <a:lstStyle/>
+          <a:p>
+            <a:pPr>
+              <a:defRPr/>
+            </a:pPr>
+            <a:fld id="{815EC703-C051-410C-8BA1-62752E291E83}" type="slidenum">
+              <a:rPr lang="en-US" altLang="en-US" smtClean="0"/>
+              <a:t>4</a:t>
+            </a:fld>
+            <a:endParaRPr lang="en-US" altLang="en-US"/>
+          </a:p>
+        </p:txBody>
+      </p:sp>
+    </p:spTree>
+  </p:cSld>
+  <p:clrMapOvr>
+    <a:masterClrMapping/>
+  </p:clrMapOvr>
+</p:sld>
+</file>
+
+<file path=ppt/slides/slide5.xml><?xml version="1.0" encoding="utf-8"?>
+<p:sld xmlns:a="http://schemas.openxmlformats.org/drawingml/2006/main" xmlns:r="http://schemas.openxmlformats.org/officeDocument/2006/relationships" xmlns:p="http://schemas.openxmlformats.org/presentationml/2006/main">
+  <p:cSld>
+    <p:spTree>
+      <p:nvGrpSpPr>
+        <p:cNvPr id="1" name=""/>
+        <p:cNvGrpSpPr/>
+        <p:nvPr/>
+      </p:nvGrpSpPr>
+      <p:grpSpPr>
+        <a:xfrm>
+          <a:off x="0" y="0"/>
+          <a:ext cx="0" cy="0"/>
+          <a:chOff x="0" y="0"/>
+          <a:chExt cx="0" cy="0"/>
+        </a:xfrm>
+      </p:grpSpPr>
+      <p:sp>
+        <p:nvSpPr>
+          <p:cNvPr id="2" name="Title 1"/>
+          <p:cNvSpPr>
+            <a:spLocks noGrp="1"/>
+          </p:cNvSpPr>
+          <p:nvPr>
+            <p:ph type="title"/>
+          </p:nvPr>
+        </p:nvSpPr>
+        <p:spPr>
+          <a:xfrm>
+            <a:off x="838200" y="365126"/>
+            <a:ext cx="10515600" cy="679904"/>
+          </a:xfrm>
+        </p:spPr>
+        <p:txBody>
+          <a:bodyPr/>
+          <a:lstStyle/>
+          <a:p>
+            <a:r>
+              <a:rPr lang="en-US" sz="3200" b="1" dirty="0">
+                <a:solidFill>
+                  <a:schemeClr val="accent1">
+                    <a:lumMod val="75000"/>
+                  </a:schemeClr>
+                </a:solidFill>
+                <a:latin typeface="Times New Roman" panose="02020603050405020304" pitchFamily="18" charset="0"/>
+                <a:cs typeface="Times New Roman" panose="02020603050405020304" pitchFamily="18" charset="0"/>
+              </a:rPr>
+              <a:t>About Company or Organization</a:t>
+            </a:r>
+          </a:p>
+        </p:txBody>
+      </p:sp>
+      <p:sp>
+        <p:nvSpPr>
+          <p:cNvPr id="3" name="Content Placeholder 2"/>
+          <p:cNvSpPr>
+            <a:spLocks noGrp="1"/>
+          </p:cNvSpPr>
+          <p:nvPr>
+            <p:ph idx="1"/>
+          </p:nvPr>
+        </p:nvSpPr>
+        <p:spPr>
+          <a:xfrm>
+            <a:off x="838200" y="1045031"/>
+            <a:ext cx="10515600" cy="4193176"/>
+          </a:xfrm>
+        </p:spPr>
+        <p:txBody>
+          <a:bodyPr/>
+          <a:lstStyle/>
+          <a:p>
+            <a:pPr lvl="0"/>
+            <a:r>
+              <a:rPr lang="en-IN" dirty="0"/>
+              <a:t>NVIDIA Accelerated AI Centre of Excellence </a:t>
+            </a:r>
+          </a:p>
+          <a:p>
+            <a:pPr lvl="0"/>
+            <a:r>
+              <a:rPr lang="en-IN" dirty="0"/>
+              <a:t>NVIDIA - Leading AI and GPU Computing Company </a:t>
+            </a:r>
+          </a:p>
+          <a:p>
+            <a:pPr lvl="0"/>
+            <a:r>
+              <a:rPr lang="en-IN" dirty="0"/>
+              <a:t>Focus: Accelerating AI, HPC, and Deep Learning </a:t>
+            </a:r>
+          </a:p>
+          <a:p>
+            <a:pPr lvl="0"/>
+            <a:r>
+              <a:rPr lang="en-IN" dirty="0"/>
+              <a:t>NVIDIA H200 GPU: Advanced AI Accelerator with Hopper Architecture </a:t>
+            </a:r>
+          </a:p>
+          <a:p>
+            <a:pPr lvl="0"/>
+            <a:r>
+              <a:rPr lang="en-IN" dirty="0"/>
+              <a:t>Applications: ML, DL, Computer Vision, NLP, Generative AI </a:t>
+            </a:r>
+          </a:p>
+          <a:p>
+            <a:pPr lvl="0"/>
+            <a:r>
+              <a:rPr lang="en-IN" dirty="0"/>
+              <a:t>Mission: Supporting next-generation AI infrastructure and education </a:t>
+            </a:r>
+          </a:p>
+          <a:p>
+            <a:pPr marL="0" indent="0">
+              <a:buNone/>
+            </a:pPr>
+            <a:endParaRPr lang="en-US" dirty="0">
+              <a:latin typeface="Times New Roman" panose="02020603050405020304" pitchFamily="18" charset="0"/>
+              <a:cs typeface="Times New Roman" panose="02020603050405020304" pitchFamily="18" charset="0"/>
+            </a:endParaRPr>
+          </a:p>
+        </p:txBody>
+      </p:sp>
+      <p:sp>
+        <p:nvSpPr>
+          <p:cNvPr id="4" name="Slide Number Placeholder 3"/>
+          <p:cNvSpPr>
+            <a:spLocks noGrp="1"/>
+          </p:cNvSpPr>
+          <p:nvPr>
+            <p:ph type="sldNum" sz="quarter" idx="12"/>
+          </p:nvPr>
+        </p:nvSpPr>
+        <p:spPr/>
+        <p:txBody>
+          <a:bodyPr/>
+          <a:lstStyle/>
+          <a:p>
+            <a:pPr>
+              <a:defRPr/>
+            </a:pPr>
+            <a:fld id="{815EC703-C051-410C-8BA1-62752E291E83}" type="slidenum">
+              <a:rPr lang="en-US" altLang="en-US" smtClean="0"/>
+              <a:t>5</a:t>
+            </a:fld>
+            <a:endParaRPr lang="en-US" altLang="en-US"/>
+          </a:p>
+        </p:txBody>
+      </p:sp>
+    </p:spTree>
+  </p:cSld>
+  <p:clrMapOvr>
+    <a:masterClrMapping/>
+  </p:clrMapOvr>
+</p:sld>
+</file>
+
+<file path=ppt/slides/slide6.xml><?xml version="1.0" encoding="utf-8"?>
+<p:sld xmlns:a="http://schemas.openxmlformats.org/drawingml/2006/main" xmlns:r="http://schemas.openxmlformats.org/officeDocument/2006/relationships" xmlns:p="http://schemas.openxmlformats.org/presentationml/2006/main">
+  <p:cSld>
+    <p:spTree>
+      <p:nvGrpSpPr>
+        <p:cNvPr id="1" name=""/>
+        <p:cNvGrpSpPr/>
+        <p:nvPr/>
+      </p:nvGrpSpPr>
+      <p:grpSpPr>
+        <a:xfrm>
+          <a:off x="0" y="0"/>
+          <a:ext cx="0" cy="0"/>
+          <a:chOff x="0" y="0"/>
+          <a:chExt cx="0" cy="0"/>
+        </a:xfrm>
+      </p:grpSpPr>
+      <p:sp>
+        <p:nvSpPr>
+          <p:cNvPr id="2" name="Title 1"/>
+          <p:cNvSpPr>
+            <a:spLocks noGrp="1"/>
+          </p:cNvSpPr>
+          <p:nvPr>
+            <p:ph type="title"/>
+          </p:nvPr>
+        </p:nvSpPr>
+        <p:spPr>
+          <a:xfrm>
+            <a:off x="838200" y="365125"/>
+            <a:ext cx="10515600" cy="819241"/>
+          </a:xfrm>
+        </p:spPr>
+        <p:txBody>
+          <a:bodyPr/>
+          <a:lstStyle/>
+          <a:p>
+            <a:r>
+              <a:rPr lang="en-IN" sz="3200" b="1" dirty="0">
+                <a:solidFill>
+                  <a:schemeClr val="accent1">
+                    <a:lumMod val="75000"/>
+                  </a:schemeClr>
+                </a:solidFill>
+                <a:latin typeface="Times New Roman" panose="02020603050405020304" pitchFamily="18" charset="0"/>
+                <a:cs typeface="Times New Roman" panose="02020603050405020304" pitchFamily="18" charset="0"/>
+              </a:rPr>
+              <a:t>Working domain or the technology</a:t>
+            </a:r>
+          </a:p>
+        </p:txBody>
+      </p:sp>
+      <p:sp>
+        <p:nvSpPr>
+          <p:cNvPr id="3" name="Content Placeholder 2"/>
+          <p:cNvSpPr>
+            <a:spLocks noGrp="1"/>
+          </p:cNvSpPr>
+          <p:nvPr>
+            <p:ph idx="1"/>
+          </p:nvPr>
+        </p:nvSpPr>
+        <p:spPr>
+          <a:xfrm>
+            <a:off x="838200" y="1184367"/>
+            <a:ext cx="10515600" cy="4058194"/>
+          </a:xfrm>
+        </p:spPr>
+        <p:txBody>
+          <a:bodyPr/>
+          <a:lstStyle/>
+          <a:p>
+            <a:pPr lvl="0"/>
+            <a:r>
+              <a:rPr lang="en-IN" dirty="0"/>
+              <a:t>Domain: Educational AI &amp; Natural Language Processing </a:t>
+            </a:r>
+          </a:p>
+          <a:p>
+            <a:pPr lvl="0"/>
+            <a:r>
+              <a:rPr lang="en-IN" dirty="0"/>
+              <a:t>Enterprise-Grade Retrieval-Augmented Generation (RAG)</a:t>
+            </a:r>
+          </a:p>
+          <a:p>
+            <a:pPr lvl="0"/>
+            <a:r>
+              <a:rPr lang="en-IN" dirty="0"/>
+              <a:t>Hybrid Search Pipeline combining Semantic Vectors (</a:t>
+            </a:r>
+            <a:r>
+              <a:rPr lang="en-IN" dirty="0" err="1"/>
+              <a:t>ChromaDB</a:t>
+            </a:r>
+            <a:r>
+              <a:rPr lang="en-IN" dirty="0"/>
+              <a:t>) and Lexical Matching (BM25)</a:t>
+            </a:r>
+          </a:p>
+          <a:p>
+            <a:pPr lvl="0"/>
+            <a:r>
+              <a:rPr lang="en-IN" dirty="0"/>
+              <a:t>Real-Time API Orchestration for Current Affairs Aggregation</a:t>
+            </a:r>
+          </a:p>
+          <a:p>
+            <a:pPr lvl="0"/>
+            <a:r>
+              <a:rPr lang="en-IN" dirty="0"/>
+              <a:t>Neural Machine Translation across 12 Regional Indian Languages</a:t>
+            </a:r>
+          </a:p>
+          <a:p>
+            <a:pPr lvl="0"/>
+            <a:r>
+              <a:rPr lang="en-IN" dirty="0"/>
+              <a:t>Interactive Web Application Development </a:t>
+            </a:r>
+          </a:p>
+          <a:p>
+            <a:pPr lvl="0"/>
+            <a:r>
+              <a:rPr lang="en-IN" dirty="0"/>
+              <a:t>CUDA &amp; GPU-Accelerated Computing </a:t>
+            </a:r>
+          </a:p>
+          <a:p>
+            <a:endParaRPr lang="en-IN" dirty="0">
+              <a:latin typeface="Times New Roman" panose="02020603050405020304" pitchFamily="18" charset="0"/>
+              <a:cs typeface="Times New Roman" panose="02020603050405020304" pitchFamily="18" charset="0"/>
+            </a:endParaRPr>
+          </a:p>
+        </p:txBody>
+      </p:sp>
+      <p:sp>
+        <p:nvSpPr>
+          <p:cNvPr id="4" name="Slide Number Placeholder 3"/>
+          <p:cNvSpPr>
+            <a:spLocks noGrp="1"/>
+          </p:cNvSpPr>
+          <p:nvPr>
+            <p:ph type="sldNum" sz="quarter" idx="12"/>
+          </p:nvPr>
+        </p:nvSpPr>
+        <p:spPr/>
+        <p:txBody>
+          <a:bodyPr/>
+          <a:lstStyle/>
+          <a:p>
+            <a:pPr>
+              <a:defRPr/>
+            </a:pPr>
+            <a:fld id="{815EC703-C051-410C-8BA1-62752E291E83}" type="slidenum">
+              <a:rPr lang="en-US" altLang="en-US" smtClean="0"/>
+              <a:t>6</a:t>
+            </a:fld>
+            <a:endParaRPr lang="en-US" altLang="en-US"/>
+          </a:p>
+        </p:txBody>
+      </p:sp>
+    </p:spTree>
+  </p:cSld>
+  <p:clrMapOvr>
+    <a:masterClrMapping/>
+  </p:clrMapOvr>
+</p:sld>
+</file>
+
+<file path=ppt/slides/slide7.xml><?xml version="1.0" encoding="utf-8"?>
+<p:sld xmlns:a="http://schemas.openxmlformats.org/drawingml/2006/main" xmlns:r="http://schemas.openxmlformats.org/officeDocument/2006/relationships" xmlns:p="http://schemas.openxmlformats.org/presentationml/2006/main">
+  <p:cSld>
+    <p:spTree>
+      <p:nvGrpSpPr>
+        <p:cNvPr id="1" name=""/>
+        <p:cNvGrpSpPr/>
+        <p:nvPr/>
+      </p:nvGrpSpPr>
+      <p:grpSpPr>
+        <a:xfrm>
+          <a:off x="0" y="0"/>
+          <a:ext cx="0" cy="0"/>
+          <a:chOff x="0" y="0"/>
+          <a:chExt cx="0" cy="0"/>
+        </a:xfrm>
+      </p:grpSpPr>
+      <p:sp>
+        <p:nvSpPr>
+          <p:cNvPr id="2" name="Date Placeholder 1">
+            <a:extLst>
+              <a:ext uri="{FF2B5EF4-FFF2-40B4-BE49-F238E27FC236}">
+                <a16:creationId xmlns:a16="http://schemas.microsoft.com/office/drawing/2014/main" id="{85CB2264-2444-834A-7E85-E7D089E9FB16}"/>
+              </a:ext>
+            </a:extLst>
+          </p:cNvPr>
+          <p:cNvSpPr>
+            <a:spLocks noGrp="1"/>
+          </p:cNvSpPr>
+          <p:nvPr>
+            <p:ph type="dt" sz="half" idx="10"/>
+          </p:nvPr>
+        </p:nvSpPr>
+        <p:spPr/>
+        <p:txBody>
+          <a:bodyPr/>
+          <a:lstStyle/>
+          <a:p>
+            <a:fld id="{D2BE2297-DC8B-48E6-B6D6-34773F9A5984}" type="datetime1">
+              <a:rPr lang="en-IN" smtClean="0"/>
+              <a:t>22-08-2026</a:t>
+            </a:fld>
+            <a:endParaRPr lang="en-IN" dirty="0"/>
+          </a:p>
+        </p:txBody>
+      </p:sp>
+      <p:sp>
+        <p:nvSpPr>
+          <p:cNvPr id="3" name="Slide Number Placeholder 2">
+            <a:extLst>
+              <a:ext uri="{FF2B5EF4-FFF2-40B4-BE49-F238E27FC236}">
+                <a16:creationId xmlns:a16="http://schemas.microsoft.com/office/drawing/2014/main" id="{68A0F944-B514-843C-6F1E-0240A5C69F62}"/>
+              </a:ext>
+            </a:extLst>
+          </p:cNvPr>
+          <p:cNvSpPr>
+            <a:spLocks noGrp="1"/>
+          </p:cNvSpPr>
+          <p:nvPr>
+            <p:ph type="sldNum" sz="quarter" idx="12"/>
+          </p:nvPr>
+        </p:nvSpPr>
+        <p:spPr/>
+        <p:txBody>
+          <a:bodyPr/>
+          <a:lstStyle/>
+          <a:p>
+            <a:fld id="{F32F6845-8F47-4AB8-B9CE-96D88E741707}" type="slidenum">
+              <a:rPr lang="en-IN" smtClean="0"/>
+              <a:t>7</a:t>
+            </a:fld>
+            <a:endParaRPr lang="en-IN" dirty="0"/>
+          </a:p>
+        </p:txBody>
+      </p:sp>
+      <p:sp>
+        <p:nvSpPr>
+          <p:cNvPr id="5" name="TextBox 4">
+            <a:extLst>
+              <a:ext uri="{FF2B5EF4-FFF2-40B4-BE49-F238E27FC236}">
+                <a16:creationId xmlns:a16="http://schemas.microsoft.com/office/drawing/2014/main" id="{6CECE51A-FE0A-B786-A06E-69AEE9C1C5A0}"/>
+              </a:ext>
+            </a:extLst>
+          </p:cNvPr>
+          <p:cNvSpPr txBox="1"/>
+          <p:nvPr/>
+        </p:nvSpPr>
+        <p:spPr>
+          <a:xfrm>
+            <a:off x="98612" y="0"/>
+            <a:ext cx="12093388" cy="5909310"/>
+          </a:xfrm>
+          <a:prstGeom prst="rect">
+            <a:avLst/>
+          </a:prstGeom>
+          <a:noFill/>
+        </p:spPr>
+        <p:txBody>
+          <a:bodyPr wrap="square">
+            <a:spAutoFit/>
+          </a:bodyPr>
+          <a:lstStyle/>
+          <a:p>
+            <a:r>
+              <a:rPr lang="en-IN" dirty="0"/>
+              <a:t>Frontend Specifications</a:t>
+            </a:r>
+          </a:p>
+          <a:p>
+            <a:pPr lvl="0"/>
+            <a:r>
+              <a:rPr lang="en-IN" dirty="0"/>
+              <a:t>Framework: Next.js (React.js) with App Router</a:t>
+            </a:r>
+          </a:p>
+          <a:p>
+            <a:pPr lvl="0"/>
+            <a:r>
+              <a:rPr lang="en-IN" dirty="0"/>
+              <a:t>Language and Styling: TypeScript / JavaScript  and CSS</a:t>
+            </a:r>
+          </a:p>
+          <a:p>
+            <a:pPr lvl="0"/>
+            <a:r>
+              <a:rPr lang="en-IN" dirty="0"/>
+              <a:t>Native Web APIs: Web Speech API (for Text-to-Speech audio generation)</a:t>
+            </a:r>
+          </a:p>
+          <a:p>
+            <a:pPr lvl="0"/>
+            <a:endParaRPr lang="en-IN" dirty="0"/>
+          </a:p>
+          <a:p>
+            <a:r>
+              <a:rPr lang="en-IN" dirty="0"/>
+              <a:t>Backend Specifications</a:t>
+            </a:r>
+          </a:p>
+          <a:p>
+            <a:pPr lvl="0"/>
+            <a:r>
+              <a:rPr lang="en-IN" dirty="0"/>
+              <a:t>Framework: </a:t>
+            </a:r>
+            <a:r>
+              <a:rPr lang="en-IN" dirty="0" err="1"/>
+              <a:t>FastAPI</a:t>
+            </a:r>
+            <a:r>
+              <a:rPr lang="en-IN" dirty="0"/>
+              <a:t> (High-performance, asynchronous REST API)</a:t>
+            </a:r>
+          </a:p>
+          <a:p>
+            <a:pPr lvl="0"/>
+            <a:r>
+              <a:rPr lang="en-IN" dirty="0"/>
+              <a:t>Language: Python 3.x</a:t>
+            </a:r>
+          </a:p>
+          <a:p>
+            <a:pPr lvl="0"/>
+            <a:r>
+              <a:rPr lang="en-IN" dirty="0"/>
+              <a:t>Server: </a:t>
+            </a:r>
+            <a:r>
+              <a:rPr lang="en-IN" dirty="0" err="1"/>
+              <a:t>Uvicorn</a:t>
+            </a:r>
+            <a:r>
+              <a:rPr lang="en-IN" dirty="0"/>
+              <a:t> (ASGI web server)</a:t>
+            </a:r>
+          </a:p>
+          <a:p>
+            <a:pPr lvl="0"/>
+            <a:endParaRPr lang="en-IN" dirty="0"/>
+          </a:p>
+          <a:p>
+            <a:r>
+              <a:rPr lang="en-IN" dirty="0"/>
+              <a:t>AI &amp; Machine Learning Specs</a:t>
+            </a:r>
+          </a:p>
+          <a:p>
+            <a:pPr lvl="0"/>
+            <a:r>
+              <a:rPr lang="en-IN" dirty="0"/>
+              <a:t>Large Language Model (LLM): Meta Llama-3 (8 Billion Parameters, Instruct-tuned)</a:t>
+            </a:r>
+          </a:p>
+          <a:p>
+            <a:pPr lvl="0"/>
+            <a:r>
+              <a:rPr lang="en-IN" dirty="0"/>
+              <a:t>Inference Engine: GPT4All Python Bindings (Hardware-agnostic, edge-computing engine)</a:t>
+            </a:r>
+          </a:p>
+          <a:p>
+            <a:pPr lvl="0"/>
+            <a:r>
+              <a:rPr lang="en-IN" dirty="0"/>
+              <a:t>Vector Database: </a:t>
+            </a:r>
+            <a:r>
+              <a:rPr lang="en-IN" dirty="0" err="1"/>
+              <a:t>ChromaDB</a:t>
+            </a:r>
+            <a:r>
+              <a:rPr lang="en-IN" dirty="0"/>
+              <a:t> </a:t>
+            </a:r>
+          </a:p>
+          <a:p>
+            <a:pPr lvl="0"/>
+            <a:r>
+              <a:rPr lang="en-IN" dirty="0"/>
+              <a:t>Document Processing: PyPDF2 for text extraction</a:t>
+            </a:r>
+          </a:p>
+          <a:p>
+            <a:pPr lvl="0"/>
+            <a:endParaRPr lang="en-IN" dirty="0"/>
+          </a:p>
+          <a:p>
+            <a:r>
+              <a:rPr lang="en-IN" dirty="0"/>
+              <a:t>Architecture &amp; Deployment</a:t>
+            </a:r>
+          </a:p>
+          <a:p>
+            <a:pPr lvl="0"/>
+            <a:r>
+              <a:rPr lang="en-IN" dirty="0"/>
+              <a:t>System Architecture: Decoupled Client-Server Architecture (REST API)</a:t>
+            </a:r>
+          </a:p>
+          <a:p>
+            <a:pPr lvl="0"/>
+            <a:r>
+              <a:rPr lang="en-IN" dirty="0"/>
+              <a:t>Deployment Style: Edge AI / Local On-Premise Hosting</a:t>
+            </a:r>
+          </a:p>
+          <a:p>
+            <a:pPr lvl="0"/>
+            <a:r>
+              <a:rPr lang="en-IN" dirty="0"/>
+              <a:t>Networking: Bound to Local Area Network (LAN) via 0.0.0.0</a:t>
+            </a:r>
+          </a:p>
+          <a:p>
+            <a:pPr lvl="0"/>
+            <a:r>
+              <a:rPr lang="en-IN" dirty="0"/>
+              <a:t>Access Control: Allows cross-device access (Mobile/Tablet) via IPv4 routing without internet access</a:t>
+            </a:r>
+          </a:p>
+        </p:txBody>
+      </p:sp>
+    </p:spTree>
+    <p:extLst>
+      <p:ext uri="{BB962C8B-B14F-4D97-AF65-F5344CB8AC3E}">
+        <p14:creationId xmlns:p14="http://schemas.microsoft.com/office/powerpoint/2010/main" val="994300098"/>
+      </p:ext>
+    </p:extLst>
+  </p:cSld>
+  <p:clrMapOvr>
+    <a:masterClrMapping/>
+  </p:clrMapOvr>
+</p:sld>
+</file>
+
+<file path=ppt/slides/slide8.xml><?xml version="1.0" encoding="utf-8"?>
+<p:sld xmlns:a="http://schemas.openxmlformats.org/drawingml/2006/main" xmlns:r="http://schemas.openxmlformats.org/officeDocument/2006/relationships" xmlns:p="http://schemas.openxmlformats.org/presentationml/2006/main">
+  <p:cSld>
+    <p:spTree>
+      <p:nvGrpSpPr>
+        <p:cNvPr id="1" name=""/>
+        <p:cNvGrpSpPr/>
+        <p:nvPr/>
+      </p:nvGrpSpPr>
+      <p:grpSpPr>
+        <a:xfrm>
+          <a:off x="0" y="0"/>
+          <a:ext cx="0" cy="0"/>
+          <a:chOff x="0" y="0"/>
+          <a:chExt cx="0" cy="0"/>
+        </a:xfrm>
+      </p:grpSpPr>
+      <p:sp>
+        <p:nvSpPr>
+          <p:cNvPr id="2" name="Title 1"/>
+          <p:cNvSpPr>
+            <a:spLocks noGrp="1"/>
+          </p:cNvSpPr>
+          <p:nvPr>
+            <p:ph type="title"/>
+          </p:nvPr>
+        </p:nvSpPr>
+        <p:spPr>
+          <a:xfrm>
+            <a:off x="838200" y="365125"/>
+            <a:ext cx="10515600" cy="819241"/>
+          </a:xfrm>
+        </p:spPr>
+        <p:txBody>
+          <a:bodyPr/>
+          <a:lstStyle/>
+          <a:p>
+            <a:r>
+              <a:rPr lang="en-IN" sz="3200" b="1" dirty="0">
+                <a:solidFill>
+                  <a:schemeClr val="accent1">
+                    <a:lumMod val="75000"/>
+                  </a:schemeClr>
+                </a:solidFill>
+                <a:latin typeface="Times New Roman" panose="02020603050405020304" pitchFamily="18" charset="0"/>
+                <a:cs typeface="Times New Roman" panose="02020603050405020304" pitchFamily="18" charset="0"/>
+              </a:rPr>
+              <a:t>Challenges Faced in Internship</a:t>
+            </a:r>
+          </a:p>
+        </p:txBody>
+      </p:sp>
+      <p:sp>
+        <p:nvSpPr>
+          <p:cNvPr id="3" name="Content Placeholder 2"/>
+          <p:cNvSpPr>
+            <a:spLocks noGrp="1"/>
+          </p:cNvSpPr>
+          <p:nvPr>
+            <p:ph idx="1"/>
+          </p:nvPr>
+        </p:nvSpPr>
+        <p:spPr>
+          <a:xfrm>
+            <a:off x="838200" y="1184367"/>
+            <a:ext cx="10515600" cy="4058194"/>
+          </a:xfrm>
+        </p:spPr>
+        <p:txBody>
+          <a:bodyPr>
+            <a:normAutofit lnSpcReduction="10000"/>
+          </a:bodyPr>
+          <a:lstStyle/>
+          <a:p>
+            <a:pPr lvl="0"/>
+            <a:r>
+              <a:rPr lang="en-IN" dirty="0"/>
+              <a:t>Learning Complex NLP &amp; Transformer Models </a:t>
+            </a:r>
+          </a:p>
+          <a:p>
+            <a:pPr lvl="0"/>
+            <a:r>
+              <a:rPr lang="en-IN" dirty="0"/>
+              <a:t>Mastering CUDA &amp; GPU Computing for AI </a:t>
+            </a:r>
+          </a:p>
+          <a:p>
+            <a:pPr lvl="0"/>
+            <a:r>
+              <a:rPr lang="en-IN" dirty="0"/>
+              <a:t>Understanding Kubernetes Container Orchestration </a:t>
+            </a:r>
+          </a:p>
+          <a:p>
+            <a:pPr lvl="0"/>
+            <a:r>
+              <a:rPr lang="en-IN" dirty="0"/>
+              <a:t>Overcoming the limitations of linear "Naive RAG" pipelines by developing robust Hybrid search algorithms.</a:t>
+            </a:r>
+          </a:p>
+          <a:p>
+            <a:pPr lvl="0"/>
+            <a:r>
+              <a:rPr lang="en-IN" dirty="0"/>
+              <a:t>Resolving silent, cascading API failures caused by environment variable mismatches between local and production deployments.</a:t>
+            </a:r>
+          </a:p>
+          <a:p>
+            <a:pPr lvl="0"/>
+            <a:r>
+              <a:rPr lang="en-IN" dirty="0"/>
+              <a:t>Bypassing rate-limiting bottlenecks from third-party news APIs via redundant failover orchestration.</a:t>
+            </a:r>
+          </a:p>
+          <a:p>
+            <a:endParaRPr lang="en-IN" dirty="0">
+              <a:latin typeface="Times New Roman" panose="02020603050405020304" pitchFamily="18" charset="0"/>
+              <a:cs typeface="Times New Roman" panose="02020603050405020304" pitchFamily="18" charset="0"/>
+            </a:endParaRPr>
+          </a:p>
+        </p:txBody>
+      </p:sp>
+      <p:sp>
+        <p:nvSpPr>
+          <p:cNvPr id="4" name="Slide Number Placeholder 3"/>
+          <p:cNvSpPr>
+            <a:spLocks noGrp="1"/>
+          </p:cNvSpPr>
+          <p:nvPr>
+            <p:ph type="sldNum" sz="quarter" idx="12"/>
+          </p:nvPr>
+        </p:nvSpPr>
+        <p:spPr/>
+        <p:txBody>
+          <a:bodyPr/>
+          <a:lstStyle/>
+          <a:p>
+            <a:pPr>
+              <a:defRPr/>
+            </a:pPr>
+            <a:fld id="{815EC703-C051-410C-8BA1-62752E291E83}" type="slidenum">
+              <a:rPr lang="en-US" altLang="en-US" smtClean="0"/>
+              <a:t>8</a:t>
+            </a:fld>
+            <a:endParaRPr lang="en-US" altLang="en-US"/>
+          </a:p>
+        </p:txBody>
+      </p:sp>
+    </p:spTree>
+  </p:cSld>
+  <p:clrMapOvr>
+    <a:masterClrMapping/>
+  </p:clrMapOvr>
+</p:sld>
+</file>
+
+<file path=ppt/slides/slide9.xml><?xml version="1.0" encoding="utf-8"?>
+<p:sld xmlns:a="http://schemas.openxmlformats.org/drawingml/2006/main" xmlns:r="http://schemas.openxmlformats.org/officeDocument/2006/relationships" xmlns:p="http://schemas.openxmlformats.org/presentationml/2006/main">
+  <p:cSld>
+    <p:spTree>
+      <p:nvGrpSpPr>
+        <p:cNvPr id="1" name=""/>
+        <p:cNvGrpSpPr/>
+        <p:nvPr/>
+      </p:nvGrpSpPr>
+      <p:grpSpPr>
+        <a:xfrm>
+          <a:off x="0" y="0"/>
+          <a:ext cx="0" cy="0"/>
+          <a:chOff x="0" y="0"/>
+          <a:chExt cx="0" cy="0"/>
+        </a:xfrm>
+      </p:grpSpPr>
+      <p:sp>
+        <p:nvSpPr>
+          <p:cNvPr id="2" name="Title 1"/>
+          <p:cNvSpPr>
+            <a:spLocks noGrp="1"/>
+          </p:cNvSpPr>
+          <p:nvPr>
+            <p:ph type="title"/>
+          </p:nvPr>
+        </p:nvSpPr>
+        <p:spPr>
+          <a:xfrm>
+            <a:off x="838200" y="365125"/>
+            <a:ext cx="10515600" cy="596311"/>
+          </a:xfrm>
+        </p:spPr>
+        <p:txBody>
+          <a:bodyPr/>
+          <a:lstStyle/>
+          <a:p>
+            <a:r>
+              <a:rPr lang="en-US" sz="3200" b="1" dirty="0">
+                <a:solidFill>
+                  <a:schemeClr val="accent1">
+                    <a:lumMod val="75000"/>
+                  </a:schemeClr>
+                </a:solidFill>
+                <a:latin typeface="Times New Roman" panose="02020603050405020304" pitchFamily="18" charset="0"/>
+                <a:cs typeface="Times New Roman" panose="02020603050405020304" pitchFamily="18" charset="0"/>
+              </a:rPr>
+              <a:t>Github Link</a:t>
+            </a:r>
+          </a:p>
+        </p:txBody>
+      </p:sp>
+      <p:sp>
+        <p:nvSpPr>
+          <p:cNvPr id="4" name="Slide Number Placeholder 3"/>
+          <p:cNvSpPr>
+            <a:spLocks noGrp="1"/>
+          </p:cNvSpPr>
+          <p:nvPr>
+            <p:ph type="sldNum" sz="quarter" idx="12"/>
+          </p:nvPr>
+        </p:nvSpPr>
+        <p:spPr/>
+        <p:txBody>
+          <a:bodyPr/>
+          <a:lstStyle/>
+          <a:p>
+            <a:pPr>
+              <a:defRPr/>
+            </a:pPr>
+            <a:fld id="{815EC703-C051-410C-8BA1-62752E291E83}" type="slidenum">
+              <a:rPr lang="en-US" altLang="en-US" smtClean="0"/>
+              <a:t>9</a:t>
+            </a:fld>
+            <a:endParaRPr lang="en-US" altLang="en-US"/>
+          </a:p>
+        </p:txBody>
+      </p:sp>
+      <p:sp>
+        <p:nvSpPr>
+          <p:cNvPr id="3" name="Content Placeholder 2"/>
+          <p:cNvSpPr>
+            <a:spLocks noGrp="1"/>
+          </p:cNvSpPr>
+          <p:nvPr>
+            <p:ph idx="1"/>
+          </p:nvPr>
+        </p:nvSpPr>
+        <p:spPr>
+          <a:xfrm>
+            <a:off x="446308" y="1061297"/>
+            <a:ext cx="10515600" cy="4351338"/>
+          </a:xfrm>
+        </p:spPr>
+        <p:txBody>
+          <a:bodyPr/>
+          <a:lstStyle/>
+          <a:p>
+            <a:r>
+              <a:rPr lang="en-US" altLang="en-US" dirty="0"/>
+              <a:t>https://github.com/ROHAN-BLAZEY/bharat-study-chatbot</a:t>
+            </a:r>
+          </a:p>
+        </p:txBody>
+      </p:sp>
     </p:spTree>
   </p:cSld>
   <p:clrMapOvr>

</xml_diff>

<commit_message>
Fixed severe generator bug suppressing responses and added quick action shortcuts
</commit_message>
<xml_diff>
--- a/Internship Capstone Project/CSS7000-Internship Presentation.pptx
+++ b/Internship Capstone Project/CSS7000-Internship Presentation.pptx
@@ -3676,6 +3676,18 @@
               <a:buNone/>
             </a:pPr>
             <a:r>
+              <a:rPr lang="en-GB" sz="1700" b="1" i="0" u="none" strike="noStrike" cap="none">
+                <a:solidFill>
+                  <a:srgbClr val="17365D"/>
+                </a:solidFill>
+                <a:latin typeface="Cambria" panose="02040503050406030204" pitchFamily="18" charset="0"/>
+                <a:ea typeface="Cambria" panose="02040503050406030204" pitchFamily="18" charset="0"/>
+                <a:cs typeface="Verdana" panose="020B0604030504040204"/>
+                <a:sym typeface="Verdana" panose="020B0604030504040204"/>
+              </a:rPr>
+              <a:t>Assistant </a:t>
+            </a:r>
+            <a:r>
               <a:rPr lang="en-GB" sz="1700" b="1" i="0" u="none" strike="noStrike" cap="none" dirty="0">
                 <a:solidFill>
                   <a:srgbClr val="17365D"/>
@@ -3685,7 +3697,7 @@
                 <a:cs typeface="Verdana" panose="020B0604030504040204"/>
                 <a:sym typeface="Verdana" panose="020B0604030504040204"/>
               </a:rPr>
-              <a:t>Professor / Associate Professor / Assistant Professor</a:t>
+              <a:t>Professor</a:t>
             </a:r>
             <a:endParaRPr dirty="0">
               <a:latin typeface="Cambria" panose="02040503050406030204" pitchFamily="18" charset="0"/>

</xml_diff>